<commit_message>
Update project documentation (.docx) and presentation (.pptx)
</commit_message>
<xml_diff>
--- a/Appointment_Assistant_Capstone.pptx
+++ b/Appointment_Assistant_Capstone.pptx
@@ -11,7 +11,9 @@
     <p:sldId id="259" r:id="rId5"/>
     <p:sldId id="260" r:id="rId6"/>
     <p:sldId id="261" r:id="rId7"/>
+    <p:sldId id="269" r:id="rId20"/>
     <p:sldId id="262" r:id="rId8"/>
+    <p:sldId id="270" r:id="rId21"/>
     <p:sldId id="263" r:id="rId9"/>
     <p:sldId id="264" r:id="rId10"/>
     <p:sldId id="265" r:id="rId11"/>
@@ -2259,6 +2261,10 @@
           </a:solidFill>
           <a:ln/>
         </p:spPr>
+        <p:txBody>
+          <a:bodyPr/>
+          <a:p/>
+        </p:txBody>
       </p:sp>
       <p:sp>
         <p:nvSpPr>
@@ -2279,6 +2285,10 @@
           </a:solidFill>
           <a:ln/>
         </p:spPr>
+        <p:txBody>
+          <a:bodyPr/>
+          <a:p/>
+        </p:txBody>
       </p:sp>
       <p:sp>
         <p:nvSpPr>
@@ -2301,6 +2311,10 @@
           </a:solidFill>
           <a:ln/>
         </p:spPr>
+        <p:txBody>
+          <a:bodyPr/>
+          <a:p/>
+        </p:txBody>
       </p:sp>
       <p:pic>
         <p:nvPicPr>
@@ -2488,6 +2502,10 @@
             <a:prstDash val="solid"/>
           </a:ln>
         </p:spPr>
+        <p:txBody>
+          <a:bodyPr/>
+          <a:p/>
+        </p:txBody>
       </p:sp>
       <p:sp>
         <p:nvSpPr>
@@ -2590,6 +2608,1463 @@
 </file>
 
 <file path=ppt/slides/slide10.xml><?xml version="1.0" encoding="utf-8"?>
+<p:sld xmlns:a="http://schemas.openxmlformats.org/drawingml/2006/main" xmlns:r="http://schemas.openxmlformats.org/officeDocument/2006/relationships" xmlns:p="http://schemas.openxmlformats.org/presentationml/2006/main">
+  <p:cSld name="Slide 8">
+    <p:spTree>
+      <p:nvGrpSpPr>
+        <p:cNvPr id="1" name=""/>
+        <p:cNvGrpSpPr/>
+        <p:nvPr/>
+      </p:nvGrpSpPr>
+      <p:grpSpPr>
+        <a:xfrm>
+          <a:off x="0" y="0"/>
+          <a:ext cx="0" cy="0"/>
+          <a:chOff x="0" y="0"/>
+          <a:chExt cx="0" cy="0"/>
+        </a:xfrm>
+      </p:grpSpPr>
+      <p:sp>
+        <p:nvSpPr>
+          <p:cNvPr id="2" name="Shape 0"/>
+          <p:cNvSpPr/>
+          <p:nvPr/>
+        </p:nvSpPr>
+        <p:spPr>
+          <a:xfrm>
+            <a:off x="548640" y="475488"/>
+            <a:ext cx="585216" cy="585216"/>
+          </a:xfrm>
+          <a:prstGeom prst="ellipse">
+            <a:avLst/>
+          </a:prstGeom>
+          <a:solidFill>
+            <a:srgbClr val="028090"/>
+          </a:solidFill>
+          <a:ln/>
+        </p:spPr>
+        <p:txBody>
+          <a:bodyPr/>
+          <a:p/>
+        </p:txBody>
+      </p:sp>
+      <p:pic>
+        <p:nvPicPr>
+          <p:cNvPr id="3" name="Image 0" descr="preencoded.png">    </p:cNvPr>
+          <p:cNvPicPr>
+            <a:picLocks noChangeAspect="1"/>
+          </p:cNvPicPr>
+          <p:nvPr/>
+        </p:nvPicPr>
+        <p:blipFill>
+          <a:blip r:embed="rId1"/>
+          <a:stretch>
+            <a:fillRect/>
+          </a:stretch>
+        </p:blipFill>
+        <p:spPr>
+          <a:xfrm>
+            <a:off x="694944" y="621792"/>
+            <a:ext cx="292608" cy="292608"/>
+          </a:xfrm>
+          <a:prstGeom prst="rect">
+            <a:avLst/>
+          </a:prstGeom>
+        </p:spPr>
+      </p:pic>
+      <p:sp>
+        <p:nvSpPr>
+          <p:cNvPr id="4" name="Text 1"/>
+          <p:cNvSpPr/>
+          <p:nvPr/>
+        </p:nvSpPr>
+        <p:spPr>
+          <a:xfrm>
+            <a:off x="1335024" y="457200"/>
+            <a:ext cx="10030968" cy="621792"/>
+          </a:xfrm>
+          <a:prstGeom prst="rect">
+            <a:avLst/>
+          </a:prstGeom>
+          <a:noFill/>
+          <a:ln/>
+        </p:spPr>
+        <p:txBody>
+          <a:bodyPr wrap="square" lIns="0" tIns="0" rIns="0" bIns="0" rtlCol="0" anchor="ctr"/>
+          <a:lstStyle/>
+          <a:p>
+            <a:pPr algn="l" indent="0" marL="0">
+              <a:buNone/>
+            </a:pPr>
+            <a:r>
+              <a:rPr lang="en-US" sz="3000" b="1" dirty="0">
+                <a:solidFill>
+                  <a:srgbClr val="0E2E34"/>
+                </a:solidFill>
+                <a:latin typeface="Cambria" pitchFamily="34" charset="0"/>
+                <a:ea typeface="Cambria" pitchFamily="34" charset="-122"/>
+                <a:cs typeface="Cambria" pitchFamily="34" charset="-120"/>
+              </a:rPr>
+              <a:t>Lightning App</a:t>
+            </a:r>
+            <a:endParaRPr lang="en-US" sz="3000" dirty="0"/>
+          </a:p>
+        </p:txBody>
+      </p:sp>
+      <p:sp>
+        <p:nvSpPr>
+          <p:cNvPr id="5" name="Text 2"/>
+          <p:cNvSpPr/>
+          <p:nvPr/>
+        </p:nvSpPr>
+        <p:spPr>
+          <a:xfrm>
+            <a:off x="11183112" y="502920"/>
+            <a:ext cx="457200" cy="530352"/>
+          </a:xfrm>
+          <a:prstGeom prst="rect">
+            <a:avLst/>
+          </a:prstGeom>
+          <a:noFill/>
+          <a:ln/>
+        </p:spPr>
+        <p:txBody>
+          <a:bodyPr wrap="square" rtlCol="0" anchor="ctr"/>
+          <a:lstStyle/>
+          <a:p>
+            <a:pPr algn="r" indent="0" marL="0">
+              <a:buNone/>
+            </a:pPr>
+            <a:r>
+              <a:rPr lang="en-US" sz="1300" b="1" dirty="0">
+                <a:solidFill>
+                  <a:srgbClr val="5B7079"/>
+                </a:solidFill>
+                <a:latin typeface="Calibri" pitchFamily="34" charset="0"/>
+                <a:ea typeface="Calibri" pitchFamily="34" charset="-122"/>
+                <a:cs typeface="Calibri" pitchFamily="34" charset="-120"/>
+              </a:rPr>
+              <a:t>10</a:t>
+            </a:r>
+            <a:endParaRPr lang="en-US" sz="1300" dirty="0"/>
+          </a:p>
+        </p:txBody>
+      </p:sp>
+      <p:sp>
+        <p:nvSpPr>
+          <p:cNvPr id="6" name="Shape 3"/>
+          <p:cNvSpPr/>
+          <p:nvPr/>
+        </p:nvSpPr>
+        <p:spPr>
+          <a:xfrm>
+            <a:off x="548640" y="1261872"/>
+            <a:ext cx="1005840" cy="0"/>
+          </a:xfrm>
+          <a:prstGeom prst="line">
+            <a:avLst/>
+          </a:prstGeom>
+          <a:noFill/>
+          <a:ln w="31750">
+            <a:solidFill>
+              <a:srgbClr val="02C39A"/>
+            </a:solidFill>
+            <a:prstDash val="solid"/>
+          </a:ln>
+        </p:spPr>
+        <p:txBody>
+          <a:bodyPr/>
+          <a:p/>
+        </p:txBody>
+      </p:sp>
+      <p:sp>
+        <p:nvSpPr>
+          <p:cNvPr id="7" name="Shape 4"/>
+          <p:cNvSpPr/>
+          <p:nvPr/>
+        </p:nvSpPr>
+        <p:spPr>
+          <a:xfrm>
+            <a:off x="548640" y="1691640"/>
+            <a:ext cx="6309360" cy="3840480"/>
+          </a:xfrm>
+          <a:prstGeom prst="roundRect">
+            <a:avLst>
+              <a:gd name="adj" fmla="val 2857"/>
+            </a:avLst>
+          </a:prstGeom>
+          <a:solidFill>
+            <a:srgbClr val="FFFFFF"/>
+          </a:solidFill>
+          <a:ln w="15875">
+            <a:solidFill>
+              <a:srgbClr val="D5E2E4"/>
+            </a:solidFill>
+            <a:prstDash val="solid"/>
+          </a:ln>
+          <a:effectLst>
+            <a:outerShdw sx="100000" sy="100000" kx="0" ky="0" algn="bl" rotWithShape="0" blurRad="114300" dist="38100" dir="5400000">
+              <a:srgbClr val="AEC0C2">
+                <a:alpha val="55000"/>
+              </a:srgbClr>
+            </a:outerShdw>
+          </a:effectLst>
+        </p:spPr>
+        <p:txBody>
+          <a:bodyPr/>
+          <a:p/>
+        </p:txBody>
+      </p:sp>
+      <p:sp>
+        <p:nvSpPr>
+          <p:cNvPr id="8" name="Shape 5"/>
+          <p:cNvSpPr/>
+          <p:nvPr/>
+        </p:nvSpPr>
+        <p:spPr>
+          <a:xfrm>
+            <a:off x="548640" y="1691640"/>
+            <a:ext cx="6309360" cy="868680"/>
+          </a:xfrm>
+          <a:prstGeom prst="roundRect">
+            <a:avLst>
+              <a:gd name="adj" fmla="val 12632"/>
+            </a:avLst>
+          </a:prstGeom>
+          <a:solidFill>
+            <a:srgbClr val="0E2E34"/>
+          </a:solidFill>
+          <a:ln/>
+        </p:spPr>
+        <p:txBody>
+          <a:bodyPr/>
+          <a:p/>
+        </p:txBody>
+      </p:sp>
+      <p:sp>
+        <p:nvSpPr>
+          <p:cNvPr id="9" name="Shape 6"/>
+          <p:cNvSpPr/>
+          <p:nvPr/>
+        </p:nvSpPr>
+        <p:spPr>
+          <a:xfrm>
+            <a:off x="868680" y="1929384"/>
+            <a:ext cx="402336" cy="402336"/>
+          </a:xfrm>
+          <a:prstGeom prst="roundRect">
+            <a:avLst>
+              <a:gd name="adj" fmla="val 13636"/>
+            </a:avLst>
+          </a:prstGeom>
+          <a:solidFill>
+            <a:srgbClr val="02C39A"/>
+          </a:solidFill>
+          <a:ln/>
+        </p:spPr>
+        <p:txBody>
+          <a:bodyPr/>
+          <a:p/>
+        </p:txBody>
+      </p:sp>
+      <p:pic>
+        <p:nvPicPr>
+          <p:cNvPr id="10" name="Image 1" descr="preencoded.png">    </p:cNvPr>
+          <p:cNvPicPr>
+            <a:picLocks noChangeAspect="1"/>
+          </p:cNvPicPr>
+          <p:nvPr/>
+        </p:nvPicPr>
+        <p:blipFill>
+          <a:blip r:embed="rId2"/>
+          <a:stretch>
+            <a:fillRect/>
+          </a:stretch>
+        </p:blipFill>
+        <p:spPr>
+          <a:xfrm>
+            <a:off x="950976" y="2011680"/>
+            <a:ext cx="237744" cy="237744"/>
+          </a:xfrm>
+          <a:prstGeom prst="rect">
+            <a:avLst/>
+          </a:prstGeom>
+        </p:spPr>
+      </p:pic>
+      <p:sp>
+        <p:nvSpPr>
+          <p:cNvPr id="11" name="Text 7"/>
+          <p:cNvSpPr/>
+          <p:nvPr/>
+        </p:nvSpPr>
+        <p:spPr>
+          <a:xfrm>
+            <a:off x="1417320" y="1691640"/>
+            <a:ext cx="5212080" cy="868680"/>
+          </a:xfrm>
+          <a:prstGeom prst="rect">
+            <a:avLst/>
+          </a:prstGeom>
+          <a:noFill/>
+          <a:ln/>
+        </p:spPr>
+        <p:txBody>
+          <a:bodyPr wrap="square" rtlCol="0" anchor="ctr"/>
+          <a:lstStyle/>
+          <a:p>
+            <a:pPr algn="l" indent="0" marL="0">
+              <a:buNone/>
+            </a:pPr>
+            <a:r>
+              <a:rPr lang="en-US" sz="1700" b="1" dirty="0">
+                <a:solidFill>
+                  <a:srgbClr val="FFFFFF"/>
+                </a:solidFill>
+                <a:latin typeface="Calibri" pitchFamily="34" charset="0"/>
+                <a:ea typeface="Calibri" pitchFamily="34" charset="-122"/>
+                <a:cs typeface="Calibri" pitchFamily="34" charset="-120"/>
+              </a:rPr>
+              <a:t>Appointment Management</a:t>
+            </a:r>
+            <a:endParaRPr lang="en-US" sz="1700" dirty="0"/>
+          </a:p>
+        </p:txBody>
+      </p:sp>
+      <p:sp>
+        <p:nvSpPr>
+          <p:cNvPr id="12" name="Shape 8"/>
+          <p:cNvSpPr/>
+          <p:nvPr/>
+        </p:nvSpPr>
+        <p:spPr>
+          <a:xfrm>
+            <a:off x="868680" y="2834640"/>
+            <a:ext cx="1335024" cy="502920"/>
+          </a:xfrm>
+          <a:prstGeom prst="roundRect">
+            <a:avLst>
+              <a:gd name="adj" fmla="val 50909"/>
+            </a:avLst>
+          </a:prstGeom>
+          <a:solidFill>
+            <a:srgbClr val="028090"/>
+          </a:solidFill>
+          <a:ln w="12700">
+            <a:solidFill>
+              <a:srgbClr val="D5E2E4"/>
+            </a:solidFill>
+            <a:prstDash val="solid"/>
+          </a:ln>
+        </p:spPr>
+        <p:txBody>
+          <a:bodyPr/>
+          <a:p/>
+        </p:txBody>
+      </p:sp>
+      <p:sp>
+        <p:nvSpPr>
+          <p:cNvPr id="13" name="Text 9"/>
+          <p:cNvSpPr/>
+          <p:nvPr/>
+        </p:nvSpPr>
+        <p:spPr>
+          <a:xfrm>
+            <a:off x="868680" y="2834640"/>
+            <a:ext cx="1335024" cy="502920"/>
+          </a:xfrm>
+          <a:prstGeom prst="rect">
+            <a:avLst/>
+          </a:prstGeom>
+          <a:noFill/>
+          <a:ln/>
+        </p:spPr>
+        <p:txBody>
+          <a:bodyPr wrap="square" rtlCol="0" anchor="ctr"/>
+          <a:lstStyle/>
+          <a:p>
+            <a:pPr algn="ctr" indent="0" marL="0">
+              <a:buNone/>
+            </a:pPr>
+            <a:r>
+              <a:rPr lang="en-US" sz="1150" b="1" dirty="0">
+                <a:solidFill>
+                  <a:srgbClr val="FFFFFF"/>
+                </a:solidFill>
+                <a:latin typeface="Calibri" pitchFamily="34" charset="0"/>
+                <a:ea typeface="Calibri" pitchFamily="34" charset="-122"/>
+                <a:cs typeface="Calibri" pitchFamily="34" charset="-120"/>
+              </a:rPr>
+              <a:t>Appointments</a:t>
+            </a:r>
+            <a:endParaRPr lang="en-US" sz="1150" dirty="0"/>
+          </a:p>
+        </p:txBody>
+      </p:sp>
+      <p:sp>
+        <p:nvSpPr>
+          <p:cNvPr id="14" name="Shape 10"/>
+          <p:cNvSpPr/>
+          <p:nvPr/>
+        </p:nvSpPr>
+        <p:spPr>
+          <a:xfrm>
+            <a:off x="2313432" y="2834640"/>
+            <a:ext cx="1335024" cy="502920"/>
+          </a:xfrm>
+          <a:prstGeom prst="roundRect">
+            <a:avLst>
+              <a:gd name="adj" fmla="val 50909"/>
+            </a:avLst>
+          </a:prstGeom>
+          <a:solidFill>
+            <a:srgbClr val="F1F6F7"/>
+          </a:solidFill>
+          <a:ln w="12700">
+            <a:solidFill>
+              <a:srgbClr val="D5E2E4"/>
+            </a:solidFill>
+            <a:prstDash val="solid"/>
+          </a:ln>
+        </p:spPr>
+        <p:txBody>
+          <a:bodyPr/>
+          <a:p/>
+        </p:txBody>
+      </p:sp>
+      <p:sp>
+        <p:nvSpPr>
+          <p:cNvPr id="15" name="Text 11"/>
+          <p:cNvSpPr/>
+          <p:nvPr/>
+        </p:nvSpPr>
+        <p:spPr>
+          <a:xfrm>
+            <a:off x="2313432" y="2834640"/>
+            <a:ext cx="1335024" cy="502920"/>
+          </a:xfrm>
+          <a:prstGeom prst="rect">
+            <a:avLst/>
+          </a:prstGeom>
+          <a:noFill/>
+          <a:ln/>
+        </p:spPr>
+        <p:txBody>
+          <a:bodyPr wrap="square" rtlCol="0" anchor="ctr"/>
+          <a:lstStyle/>
+          <a:p>
+            <a:pPr algn="ctr" indent="0" marL="0">
+              <a:buNone/>
+            </a:pPr>
+            <a:r>
+              <a:rPr lang="en-US" sz="1150" b="1" dirty="0">
+                <a:solidFill>
+                  <a:srgbClr val="5B7079"/>
+                </a:solidFill>
+                <a:latin typeface="Calibri" pitchFamily="34" charset="0"/>
+                <a:ea typeface="Calibri" pitchFamily="34" charset="-122"/>
+                <a:cs typeface="Calibri" pitchFamily="34" charset="-120"/>
+              </a:rPr>
+              <a:t>Contacts</a:t>
+            </a:r>
+            <a:endParaRPr lang="en-US" sz="1150" dirty="0"/>
+          </a:p>
+        </p:txBody>
+      </p:sp>
+      <p:sp>
+        <p:nvSpPr>
+          <p:cNvPr id="16" name="Shape 12"/>
+          <p:cNvSpPr/>
+          <p:nvPr/>
+        </p:nvSpPr>
+        <p:spPr>
+          <a:xfrm>
+            <a:off x="3758184" y="2834640"/>
+            <a:ext cx="1335024" cy="502920"/>
+          </a:xfrm>
+          <a:prstGeom prst="roundRect">
+            <a:avLst>
+              <a:gd name="adj" fmla="val 50909"/>
+            </a:avLst>
+          </a:prstGeom>
+          <a:solidFill>
+            <a:srgbClr val="F1F6F7"/>
+          </a:solidFill>
+          <a:ln w="12700">
+            <a:solidFill>
+              <a:srgbClr val="D5E2E4"/>
+            </a:solidFill>
+            <a:prstDash val="solid"/>
+          </a:ln>
+        </p:spPr>
+        <p:txBody>
+          <a:bodyPr/>
+          <a:p/>
+        </p:txBody>
+      </p:sp>
+      <p:sp>
+        <p:nvSpPr>
+          <p:cNvPr id="17" name="Text 13"/>
+          <p:cNvSpPr/>
+          <p:nvPr/>
+        </p:nvSpPr>
+        <p:spPr>
+          <a:xfrm>
+            <a:off x="3758184" y="2834640"/>
+            <a:ext cx="1335024" cy="502920"/>
+          </a:xfrm>
+          <a:prstGeom prst="rect">
+            <a:avLst/>
+          </a:prstGeom>
+          <a:noFill/>
+          <a:ln/>
+        </p:spPr>
+        <p:txBody>
+          <a:bodyPr wrap="square" rtlCol="0" anchor="ctr"/>
+          <a:lstStyle/>
+          <a:p>
+            <a:pPr algn="ctr" indent="0" marL="0">
+              <a:buNone/>
+            </a:pPr>
+            <a:r>
+              <a:rPr lang="en-US" sz="1150" b="1" dirty="0">
+                <a:solidFill>
+                  <a:srgbClr val="5B7079"/>
+                </a:solidFill>
+                <a:latin typeface="Calibri" pitchFamily="34" charset="0"/>
+                <a:ea typeface="Calibri" pitchFamily="34" charset="-122"/>
+                <a:cs typeface="Calibri" pitchFamily="34" charset="-120"/>
+              </a:rPr>
+              <a:t>Reports</a:t>
+            </a:r>
+            <a:endParaRPr lang="en-US" sz="1150" dirty="0"/>
+          </a:p>
+        </p:txBody>
+      </p:sp>
+      <p:sp>
+        <p:nvSpPr>
+          <p:cNvPr id="18" name="Shape 14"/>
+          <p:cNvSpPr/>
+          <p:nvPr/>
+        </p:nvSpPr>
+        <p:spPr>
+          <a:xfrm>
+            <a:off x="5202936" y="2834640"/>
+            <a:ext cx="1335024" cy="502920"/>
+          </a:xfrm>
+          <a:prstGeom prst="roundRect">
+            <a:avLst>
+              <a:gd name="adj" fmla="val 50909"/>
+            </a:avLst>
+          </a:prstGeom>
+          <a:solidFill>
+            <a:srgbClr val="F1F6F7"/>
+          </a:solidFill>
+          <a:ln w="12700">
+            <a:solidFill>
+              <a:srgbClr val="D5E2E4"/>
+            </a:solidFill>
+            <a:prstDash val="solid"/>
+          </a:ln>
+        </p:spPr>
+        <p:txBody>
+          <a:bodyPr/>
+          <a:p/>
+        </p:txBody>
+      </p:sp>
+      <p:sp>
+        <p:nvSpPr>
+          <p:cNvPr id="19" name="Text 15"/>
+          <p:cNvSpPr/>
+          <p:nvPr/>
+        </p:nvSpPr>
+        <p:spPr>
+          <a:xfrm>
+            <a:off x="5202936" y="2834640"/>
+            <a:ext cx="1335024" cy="502920"/>
+          </a:xfrm>
+          <a:prstGeom prst="rect">
+            <a:avLst/>
+          </a:prstGeom>
+          <a:noFill/>
+          <a:ln/>
+        </p:spPr>
+        <p:txBody>
+          <a:bodyPr wrap="square" rtlCol="0" anchor="ctr"/>
+          <a:lstStyle/>
+          <a:p>
+            <a:pPr algn="ctr" indent="0" marL="0">
+              <a:buNone/>
+            </a:pPr>
+            <a:r>
+              <a:rPr lang="en-US" sz="1150" b="1" dirty="0">
+                <a:solidFill>
+                  <a:srgbClr val="5B7079"/>
+                </a:solidFill>
+                <a:latin typeface="Calibri" pitchFamily="34" charset="0"/>
+                <a:ea typeface="Calibri" pitchFamily="34" charset="-122"/>
+                <a:cs typeface="Calibri" pitchFamily="34" charset="-120"/>
+              </a:rPr>
+              <a:t>Dashboards</a:t>
+            </a:r>
+            <a:endParaRPr lang="en-US" sz="1150" dirty="0"/>
+          </a:p>
+        </p:txBody>
+      </p:sp>
+      <p:sp>
+        <p:nvSpPr>
+          <p:cNvPr id="20" name="Shape 16"/>
+          <p:cNvSpPr/>
+          <p:nvPr/>
+        </p:nvSpPr>
+        <p:spPr>
+          <a:xfrm>
+            <a:off x="868680" y="3566160"/>
+            <a:ext cx="5669280" cy="457200"/>
+          </a:xfrm>
+          <a:prstGeom prst="roundRect">
+            <a:avLst>
+              <a:gd name="adj" fmla="val 12000"/>
+            </a:avLst>
+          </a:prstGeom>
+          <a:solidFill>
+            <a:srgbClr val="F1F6F7"/>
+          </a:solidFill>
+          <a:ln w="12700">
+            <a:solidFill>
+              <a:srgbClr val="D5E2E4"/>
+            </a:solidFill>
+            <a:prstDash val="solid"/>
+          </a:ln>
+        </p:spPr>
+        <p:txBody>
+          <a:bodyPr/>
+          <a:p/>
+        </p:txBody>
+      </p:sp>
+      <p:sp>
+        <p:nvSpPr>
+          <p:cNvPr id="21" name="Text 17"/>
+          <p:cNvSpPr/>
+          <p:nvPr/>
+        </p:nvSpPr>
+        <p:spPr>
+          <a:xfrm>
+            <a:off x="1051560" y="3566160"/>
+            <a:ext cx="5394960" cy="457200"/>
+          </a:xfrm>
+          <a:prstGeom prst="rect">
+            <a:avLst/>
+          </a:prstGeom>
+          <a:noFill/>
+          <a:ln/>
+        </p:spPr>
+        <p:txBody>
+          <a:bodyPr wrap="square" rtlCol="0" anchor="ctr"/>
+          <a:lstStyle/>
+          <a:p>
+            <a:pPr algn="l" indent="0" marL="0">
+              <a:buNone/>
+            </a:pPr>
+            <a:r>
+              <a:rPr lang="en-US" sz="1200" dirty="0">
+                <a:solidFill>
+                  <a:srgbClr val="0E2E34"/>
+                </a:solidFill>
+                <a:latin typeface="Courier New" pitchFamily="34" charset="0"/>
+                <a:ea typeface="Courier New" pitchFamily="34" charset="-122"/>
+                <a:cs typeface="Courier New" pitchFamily="34" charset="-120"/>
+              </a:rPr>
+              <a:t>APT-00001   ·   Scheduled</a:t>
+            </a:r>
+            <a:endParaRPr lang="en-US" sz="1200" dirty="0"/>
+          </a:p>
+        </p:txBody>
+      </p:sp>
+      <p:sp>
+        <p:nvSpPr>
+          <p:cNvPr id="22" name="Shape 18"/>
+          <p:cNvSpPr/>
+          <p:nvPr/>
+        </p:nvSpPr>
+        <p:spPr>
+          <a:xfrm>
+            <a:off x="868680" y="4133088"/>
+            <a:ext cx="5669280" cy="457200"/>
+          </a:xfrm>
+          <a:prstGeom prst="roundRect">
+            <a:avLst>
+              <a:gd name="adj" fmla="val 12000"/>
+            </a:avLst>
+          </a:prstGeom>
+          <a:solidFill>
+            <a:srgbClr val="FFFFFF"/>
+          </a:solidFill>
+          <a:ln w="12700">
+            <a:solidFill>
+              <a:srgbClr val="D5E2E4"/>
+            </a:solidFill>
+            <a:prstDash val="solid"/>
+          </a:ln>
+        </p:spPr>
+        <p:txBody>
+          <a:bodyPr/>
+          <a:p/>
+        </p:txBody>
+      </p:sp>
+      <p:sp>
+        <p:nvSpPr>
+          <p:cNvPr id="23" name="Text 19"/>
+          <p:cNvSpPr/>
+          <p:nvPr/>
+        </p:nvSpPr>
+        <p:spPr>
+          <a:xfrm>
+            <a:off x="1051560" y="4133088"/>
+            <a:ext cx="5394960" cy="457200"/>
+          </a:xfrm>
+          <a:prstGeom prst="rect">
+            <a:avLst/>
+          </a:prstGeom>
+          <a:noFill/>
+          <a:ln/>
+        </p:spPr>
+        <p:txBody>
+          <a:bodyPr wrap="square" rtlCol="0" anchor="ctr"/>
+          <a:lstStyle/>
+          <a:p>
+            <a:pPr algn="l" indent="0" marL="0">
+              <a:buNone/>
+            </a:pPr>
+            <a:r>
+              <a:rPr lang="en-US" sz="1200" dirty="0">
+                <a:solidFill>
+                  <a:srgbClr val="0E2E34"/>
+                </a:solidFill>
+                <a:latin typeface="Courier New" pitchFamily="34" charset="0"/>
+                <a:ea typeface="Courier New" pitchFamily="34" charset="-122"/>
+                <a:cs typeface="Courier New" pitchFamily="34" charset="-120"/>
+              </a:rPr>
+              <a:t>APT-00002   ·   Scheduled</a:t>
+            </a:r>
+            <a:endParaRPr lang="en-US" sz="1200" dirty="0"/>
+          </a:p>
+        </p:txBody>
+      </p:sp>
+      <p:sp>
+        <p:nvSpPr>
+          <p:cNvPr id="24" name="Shape 20"/>
+          <p:cNvSpPr/>
+          <p:nvPr/>
+        </p:nvSpPr>
+        <p:spPr>
+          <a:xfrm>
+            <a:off x="868680" y="4700016"/>
+            <a:ext cx="5669280" cy="457200"/>
+          </a:xfrm>
+          <a:prstGeom prst="roundRect">
+            <a:avLst>
+              <a:gd name="adj" fmla="val 12000"/>
+            </a:avLst>
+          </a:prstGeom>
+          <a:solidFill>
+            <a:srgbClr val="F1F6F7"/>
+          </a:solidFill>
+          <a:ln w="12700">
+            <a:solidFill>
+              <a:srgbClr val="D5E2E4"/>
+            </a:solidFill>
+            <a:prstDash val="solid"/>
+          </a:ln>
+        </p:spPr>
+        <p:txBody>
+          <a:bodyPr/>
+          <a:p/>
+        </p:txBody>
+      </p:sp>
+      <p:sp>
+        <p:nvSpPr>
+          <p:cNvPr id="25" name="Text 21"/>
+          <p:cNvSpPr/>
+          <p:nvPr/>
+        </p:nvSpPr>
+        <p:spPr>
+          <a:xfrm>
+            <a:off x="1051560" y="4700016"/>
+            <a:ext cx="5394960" cy="457200"/>
+          </a:xfrm>
+          <a:prstGeom prst="rect">
+            <a:avLst/>
+          </a:prstGeom>
+          <a:noFill/>
+          <a:ln/>
+        </p:spPr>
+        <p:txBody>
+          <a:bodyPr wrap="square" rtlCol="0" anchor="ctr"/>
+          <a:lstStyle/>
+          <a:p>
+            <a:pPr algn="l" indent="0" marL="0">
+              <a:buNone/>
+            </a:pPr>
+            <a:r>
+              <a:rPr lang="en-US" sz="1200" dirty="0">
+                <a:solidFill>
+                  <a:srgbClr val="0E2E34"/>
+                </a:solidFill>
+                <a:latin typeface="Courier New" pitchFamily="34" charset="0"/>
+                <a:ea typeface="Courier New" pitchFamily="34" charset="-122"/>
+                <a:cs typeface="Courier New" pitchFamily="34" charset="-120"/>
+              </a:rPr>
+              <a:t>APT-00003   ·   Scheduled</a:t>
+            </a:r>
+            <a:endParaRPr lang="en-US" sz="1200" dirty="0"/>
+          </a:p>
+        </p:txBody>
+      </p:sp>
+      <p:sp>
+        <p:nvSpPr>
+          <p:cNvPr id="26" name="Text 22"/>
+          <p:cNvSpPr/>
+          <p:nvPr/>
+        </p:nvSpPr>
+        <p:spPr>
+          <a:xfrm>
+            <a:off x="7086600" y="1828800"/>
+            <a:ext cx="4572000" cy="3657600"/>
+          </a:xfrm>
+          <a:prstGeom prst="rect">
+            <a:avLst/>
+          </a:prstGeom>
+          <a:noFill/>
+          <a:ln/>
+        </p:spPr>
+        <p:txBody>
+          <a:bodyPr wrap="square" rtlCol="0" anchor="t"/>
+          <a:lstStyle/>
+          <a:p>
+            <a:pPr algn="l" marL="203200" indent="-203200">
+              <a:spcAft>
+                <a:spcPts val="1400"/>
+              </a:spcAft>
+              <a:buSzPct val="100000"/>
+              <a:buChar char="•"/>
+            </a:pPr>
+            <a:r>
+              <a:rPr lang="en-US" sz="1500" dirty="0">
+                <a:solidFill>
+                  <a:srgbClr val="0E2E34"/>
+                </a:solidFill>
+                <a:latin typeface="Calibri" pitchFamily="34" charset="0"/>
+                <a:ea typeface="Calibri" pitchFamily="34" charset="-122"/>
+                <a:cs typeface="Calibri" pitchFamily="34" charset="-120"/>
+              </a:rPr>
+              <a:t>"Appointment Management" Lightning App.</a:t>
+            </a:r>
+            <a:endParaRPr lang="en-US" sz="1500" dirty="0"/>
+          </a:p>
+          <a:p>
+            <a:pPr algn="l" marL="203200" indent="-203200">
+              <a:spcAft>
+                <a:spcPts val="1400"/>
+              </a:spcAft>
+              <a:buSzPct val="100000"/>
+              <a:buChar char="•"/>
+            </a:pPr>
+            <a:r>
+              <a:rPr lang="en-US" sz="1500" dirty="0">
+                <a:solidFill>
+                  <a:srgbClr val="0E2E34"/>
+                </a:solidFill>
+                <a:latin typeface="Calibri" pitchFamily="34" charset="0"/>
+                <a:ea typeface="Calibri" pitchFamily="34" charset="-122"/>
+                <a:cs typeface="Calibri" pitchFamily="34" charset="-120"/>
+              </a:rPr>
+              <a:t>Tabs: Appointments, Contacts, Reports, Dashboards.</a:t>
+            </a:r>
+            <a:endParaRPr lang="en-US" sz="1500" dirty="0"/>
+          </a:p>
+          <a:p>
+            <a:pPr algn="l" marL="203200" indent="-203200">
+              <a:spcAft>
+                <a:spcPts val="1400"/>
+              </a:spcAft>
+              <a:buSzPct val="100000"/>
+              <a:buChar char="•"/>
+            </a:pPr>
+            <a:r>
+              <a:rPr lang="en-US" sz="1500" dirty="0">
+                <a:solidFill>
+                  <a:srgbClr val="0E2E34"/>
+                </a:solidFill>
+                <a:latin typeface="Calibri" pitchFamily="34" charset="0"/>
+                <a:ea typeface="Calibri" pitchFamily="34" charset="-122"/>
+                <a:cs typeface="Calibri" pitchFamily="34" charset="-120"/>
+              </a:rPr>
+              <a:t>Custom Tab created for the Appointment object.</a:t>
+            </a:r>
+            <a:endParaRPr lang="en-US" sz="1500" dirty="0"/>
+          </a:p>
+          <a:p>
+            <a:pPr algn="l" marL="203200" indent="-203200">
+              <a:spcAft>
+                <a:spcPts val="1400"/>
+              </a:spcAft>
+              <a:buSzPct val="100000"/>
+              <a:buChar char="•"/>
+            </a:pPr>
+            <a:r>
+              <a:rPr lang="en-US" sz="1500" dirty="0">
+                <a:solidFill>
+                  <a:srgbClr val="0E2E34"/>
+                </a:solidFill>
+                <a:latin typeface="Calibri" pitchFamily="34" charset="0"/>
+                <a:ea typeface="Calibri" pitchFamily="34" charset="-122"/>
+                <a:cs typeface="Calibri" pitchFamily="34" charset="-120"/>
+              </a:rPr>
+              <a:t>Assigned to the System Administrator profile.</a:t>
+            </a:r>
+            <a:endParaRPr lang="en-US" sz="1500" dirty="0"/>
+          </a:p>
+          <a:p>
+            <a:pPr algn="l" marL="203200" indent="-203200">
+              <a:buSzPct val="100000"/>
+              <a:buChar char="•"/>
+            </a:pPr>
+            <a:r>
+              <a:rPr lang="en-US" sz="1500" dirty="0">
+                <a:solidFill>
+                  <a:srgbClr val="0E2E34"/>
+                </a:solidFill>
+                <a:latin typeface="Calibri" pitchFamily="34" charset="0"/>
+                <a:ea typeface="Calibri" pitchFamily="34" charset="-122"/>
+                <a:cs typeface="Calibri" pitchFamily="34" charset="-120"/>
+              </a:rPr>
+              <a:t>Central workspace for agents and admins.</a:t>
+            </a:r>
+            <a:endParaRPr lang="en-US" sz="1500" dirty="0"/>
+          </a:p>
+        </p:txBody>
+      </p:sp>
+      <p:sp>
+        <p:nvSpPr>
+          <p:cNvPr id="27" name="Text 23"/>
+          <p:cNvSpPr/>
+          <p:nvPr/>
+        </p:nvSpPr>
+        <p:spPr>
+          <a:xfrm>
+            <a:off x="548640" y="6446520"/>
+            <a:ext cx="8229600" cy="274320"/>
+          </a:xfrm>
+          <a:prstGeom prst="rect">
+            <a:avLst/>
+          </a:prstGeom>
+          <a:noFill/>
+          <a:ln/>
+        </p:spPr>
+        <p:txBody>
+          <a:bodyPr wrap="square" rtlCol="0" anchor="ctr"/>
+          <a:lstStyle/>
+          <a:p>
+            <a:pPr algn="l" indent="0" marL="0">
+              <a:buNone/>
+            </a:pPr>
+            <a:r>
+              <a:rPr lang="en-US" sz="900" dirty="0">
+                <a:solidFill>
+                  <a:srgbClr val="5B7079"/>
+                </a:solidFill>
+                <a:latin typeface="Calibri" pitchFamily="34" charset="0"/>
+                <a:ea typeface="Calibri" pitchFamily="34" charset="-122"/>
+                <a:cs typeface="Calibri" pitchFamily="34" charset="-120"/>
+              </a:rPr>
+              <a:t>AI-Powered Appointment Management Assistant  ·  Salesforce Capstone</a:t>
+            </a:r>
+            <a:endParaRPr lang="en-US" sz="900" dirty="0"/>
+          </a:p>
+        </p:txBody>
+      </p:sp>
+    </p:spTree>
+  </p:cSld>
+  <p:clrMapOvr>
+    <a:masterClrMapping/>
+  </p:clrMapOvr>
+</p:sld>
+</file>
+
+<file path=ppt/slides/slide11.xml><?xml version="1.0" encoding="utf-8"?>
+<p:sld xmlns:a="http://schemas.openxmlformats.org/drawingml/2006/main" xmlns:r="http://schemas.openxmlformats.org/officeDocument/2006/relationships" xmlns:p="http://schemas.openxmlformats.org/presentationml/2006/main">
+  <p:cSld name="Slide 9">
+    <p:spTree>
+      <p:nvGrpSpPr>
+        <p:cNvPr id="1" name=""/>
+        <p:cNvGrpSpPr/>
+        <p:nvPr/>
+      </p:nvGrpSpPr>
+      <p:grpSpPr>
+        <a:xfrm>
+          <a:off x="0" y="0"/>
+          <a:ext cx="0" cy="0"/>
+          <a:chOff x="0" y="0"/>
+          <a:chExt cx="0" cy="0"/>
+        </a:xfrm>
+      </p:grpSpPr>
+      <p:sp>
+        <p:nvSpPr>
+          <p:cNvPr id="2" name="Shape 0"/>
+          <p:cNvSpPr/>
+          <p:nvPr/>
+        </p:nvSpPr>
+        <p:spPr>
+          <a:xfrm>
+            <a:off x="548640" y="475488"/>
+            <a:ext cx="585216" cy="585216"/>
+          </a:xfrm>
+          <a:prstGeom prst="ellipse">
+            <a:avLst/>
+          </a:prstGeom>
+          <a:solidFill>
+            <a:srgbClr val="028090"/>
+          </a:solidFill>
+          <a:ln/>
+        </p:spPr>
+        <p:txBody>
+          <a:bodyPr/>
+          <a:p/>
+        </p:txBody>
+      </p:sp>
+      <p:pic>
+        <p:nvPicPr>
+          <p:cNvPr id="3" name="Image 0" descr="preencoded.png">    </p:cNvPr>
+          <p:cNvPicPr>
+            <a:picLocks noChangeAspect="1"/>
+          </p:cNvPicPr>
+          <p:nvPr/>
+        </p:nvPicPr>
+        <p:blipFill>
+          <a:blip r:embed="rId1"/>
+          <a:stretch>
+            <a:fillRect/>
+          </a:stretch>
+        </p:blipFill>
+        <p:spPr>
+          <a:xfrm>
+            <a:off x="694944" y="621792"/>
+            <a:ext cx="292608" cy="292608"/>
+          </a:xfrm>
+          <a:prstGeom prst="rect">
+            <a:avLst/>
+          </a:prstGeom>
+        </p:spPr>
+      </p:pic>
+      <p:sp>
+        <p:nvSpPr>
+          <p:cNvPr id="4" name="Text 1"/>
+          <p:cNvSpPr/>
+          <p:nvPr/>
+        </p:nvSpPr>
+        <p:spPr>
+          <a:xfrm>
+            <a:off x="1335024" y="457200"/>
+            <a:ext cx="10030968" cy="621792"/>
+          </a:xfrm>
+          <a:prstGeom prst="rect">
+            <a:avLst/>
+          </a:prstGeom>
+          <a:noFill/>
+          <a:ln/>
+        </p:spPr>
+        <p:txBody>
+          <a:bodyPr wrap="square" lIns="0" tIns="0" rIns="0" bIns="0" rtlCol="0" anchor="ctr"/>
+          <a:lstStyle/>
+          <a:p>
+            <a:pPr algn="l" indent="0" marL="0">
+              <a:buNone/>
+            </a:pPr>
+            <a:r>
+              <a:rPr lang="en-US" sz="3000" b="1" dirty="0">
+                <a:solidFill>
+                  <a:srgbClr val="0E2E34"/>
+                </a:solidFill>
+                <a:latin typeface="Cambria" pitchFamily="34" charset="0"/>
+                <a:ea typeface="Cambria" pitchFamily="34" charset="-122"/>
+                <a:cs typeface="Cambria" pitchFamily="34" charset="-120"/>
+              </a:rPr>
+              <a:t>Reports &amp; Dashboard</a:t>
+            </a:r>
+            <a:endParaRPr lang="en-US" sz="3000" dirty="0"/>
+          </a:p>
+        </p:txBody>
+      </p:sp>
+      <p:sp>
+        <p:nvSpPr>
+          <p:cNvPr id="5" name="Text 2"/>
+          <p:cNvSpPr/>
+          <p:nvPr/>
+        </p:nvSpPr>
+        <p:spPr>
+          <a:xfrm>
+            <a:off x="11183112" y="502920"/>
+            <a:ext cx="457200" cy="530352"/>
+          </a:xfrm>
+          <a:prstGeom prst="rect">
+            <a:avLst/>
+          </a:prstGeom>
+          <a:noFill/>
+          <a:ln/>
+        </p:spPr>
+        <p:txBody>
+          <a:bodyPr wrap="square" rtlCol="0" anchor="ctr"/>
+          <a:lstStyle/>
+          <a:p>
+            <a:pPr algn="r" indent="0" marL="0">
+              <a:buNone/>
+            </a:pPr>
+            <a:r>
+              <a:rPr lang="en-US" sz="1300" b="1" dirty="0">
+                <a:solidFill>
+                  <a:srgbClr val="5B7079"/>
+                </a:solidFill>
+                <a:latin typeface="Calibri" pitchFamily="34" charset="0"/>
+                <a:ea typeface="Calibri" pitchFamily="34" charset="-122"/>
+                <a:cs typeface="Calibri" pitchFamily="34" charset="-120"/>
+              </a:rPr>
+              <a:t>11</a:t>
+            </a:r>
+            <a:endParaRPr lang="en-US" sz="1300" dirty="0"/>
+          </a:p>
+        </p:txBody>
+      </p:sp>
+      <p:sp>
+        <p:nvSpPr>
+          <p:cNvPr id="6" name="Shape 3"/>
+          <p:cNvSpPr/>
+          <p:nvPr/>
+        </p:nvSpPr>
+        <p:spPr>
+          <a:xfrm>
+            <a:off x="548640" y="1261872"/>
+            <a:ext cx="1005840" cy="0"/>
+          </a:xfrm>
+          <a:prstGeom prst="line">
+            <a:avLst/>
+          </a:prstGeom>
+          <a:noFill/>
+          <a:ln w="31750">
+            <a:solidFill>
+              <a:srgbClr val="02C39A"/>
+            </a:solidFill>
+            <a:prstDash val="solid"/>
+          </a:ln>
+        </p:spPr>
+        <p:txBody>
+          <a:bodyPr/>
+          <a:p/>
+        </p:txBody>
+      </p:sp>
+      <p:sp>
+        <p:nvSpPr>
+          <p:cNvPr id="7" name="Shape 4"/>
+          <p:cNvSpPr/>
+          <p:nvPr/>
+        </p:nvSpPr>
+        <p:spPr>
+          <a:xfrm>
+            <a:off x="548640" y="1600200"/>
+            <a:ext cx="6126480" cy="4297680"/>
+          </a:xfrm>
+          <a:prstGeom prst="roundRect">
+            <a:avLst>
+              <a:gd name="adj" fmla="val 2553"/>
+            </a:avLst>
+          </a:prstGeom>
+          <a:solidFill>
+            <a:srgbClr val="FFFFFF"/>
+          </a:solidFill>
+          <a:ln w="15875">
+            <a:solidFill>
+              <a:srgbClr val="D5E2E4"/>
+            </a:solidFill>
+            <a:prstDash val="solid"/>
+          </a:ln>
+          <a:effectLst>
+            <a:outerShdw sx="100000" sy="100000" kx="0" ky="0" algn="bl" rotWithShape="0" blurRad="88900" dist="25400" dir="5400000">
+              <a:srgbClr val="BCCBCD">
+                <a:alpha val="50000"/>
+              </a:srgbClr>
+            </a:outerShdw>
+          </a:effectLst>
+        </p:spPr>
+        <p:txBody>
+          <a:bodyPr/>
+          <a:p/>
+        </p:txBody>
+      </p:sp>
+      <p:sp>
+        <p:nvSpPr>
+          <p:cNvPr id="8" name="Text 5"/>
+          <p:cNvSpPr/>
+          <p:nvPr/>
+        </p:nvSpPr>
+        <p:spPr>
+          <a:xfrm>
+            <a:off x="822960" y="1783080"/>
+            <a:ext cx="5577840" cy="365760"/>
+          </a:xfrm>
+          <a:prstGeom prst="rect">
+            <a:avLst/>
+          </a:prstGeom>
+          <a:noFill/>
+          <a:ln/>
+        </p:spPr>
+        <p:txBody>
+          <a:bodyPr wrap="square" rtlCol="0" anchor="ctr"/>
+          <a:lstStyle/>
+          <a:p>
+            <a:pPr algn="l" indent="0" marL="0">
+              <a:buNone/>
+            </a:pPr>
+            <a:r>
+              <a:rPr lang="en-US" sz="1500" b="1" dirty="0">
+                <a:solidFill>
+                  <a:srgbClr val="0E2E34"/>
+                </a:solidFill>
+                <a:latin typeface="Calibri" pitchFamily="34" charset="0"/>
+                <a:ea typeface="Calibri" pitchFamily="34" charset="-122"/>
+                <a:cs typeface="Calibri" pitchFamily="34" charset="-120"/>
+              </a:rPr>
+              <a:t>Appointments by Status</a:t>
+            </a:r>
+            <a:endParaRPr lang="en-US" sz="1500" dirty="0"/>
+          </a:p>
+        </p:txBody>
+      </p:sp>
+      <p:graphicFrame>
+        <p:nvGraphicFramePr>
+          <p:cNvPr id="9" name="Chart 0" descr=""/>
+          <p:cNvGraphicFramePr/>
+          <p:nvPr/>
+        </p:nvGraphicFramePr>
+        <p:xfrm>
+          <a:off x="777240" y="2194560"/>
+          <a:ext cx="5669280" cy="3429000"/>
+        </p:xfrm>
+        <a:graphic xmlns:a="http://schemas.openxmlformats.org/drawingml/2006/main">
+          <a:graphicData uri="http://schemas.openxmlformats.org/drawingml/2006/chart">
+            <c:chart xmlns:c="http://schemas.openxmlformats.org/drawingml/2006/chart" r:id="rId2"/>
+          </a:graphicData>
+        </a:graphic>
+      </p:graphicFrame>
+      <p:sp>
+        <p:nvSpPr>
+          <p:cNvPr id="10" name="Text 6"/>
+          <p:cNvSpPr/>
+          <p:nvPr/>
+        </p:nvSpPr>
+        <p:spPr>
+          <a:xfrm>
+            <a:off x="6995160" y="1920240"/>
+            <a:ext cx="4617720" cy="3291840"/>
+          </a:xfrm>
+          <a:prstGeom prst="rect">
+            <a:avLst/>
+          </a:prstGeom>
+          <a:noFill/>
+          <a:ln/>
+        </p:spPr>
+        <p:txBody>
+          <a:bodyPr wrap="square" rtlCol="0" anchor="t"/>
+          <a:lstStyle/>
+          <a:p>
+            <a:pPr algn="l" marL="203200" indent="-203200">
+              <a:spcAft>
+                <a:spcPts val="1300"/>
+              </a:spcAft>
+              <a:buSzPct val="100000"/>
+              <a:buChar char="•"/>
+            </a:pPr>
+            <a:r>
+              <a:rPr lang="en-US" sz="1450" dirty="0">
+                <a:solidFill>
+                  <a:srgbClr val="0E2E34"/>
+                </a:solidFill>
+                <a:latin typeface="Calibri" pitchFamily="34" charset="0"/>
+                <a:ea typeface="Calibri" pitchFamily="34" charset="-122"/>
+                <a:cs typeface="Calibri" pitchFamily="34" charset="-120"/>
+              </a:rPr>
+              <a:t>Custom Report Type:  "Appointments Report".</a:t>
+            </a:r>
+            <a:endParaRPr lang="en-US" sz="1450" dirty="0"/>
+          </a:p>
+          <a:p>
+            <a:pPr algn="l" marL="203200" indent="-203200">
+              <a:spcAft>
+                <a:spcPts val="1300"/>
+              </a:spcAft>
+              <a:buSzPct val="100000"/>
+              <a:buChar char="•"/>
+            </a:pPr>
+            <a:r>
+              <a:rPr lang="en-US" sz="1450" dirty="0">
+                <a:solidFill>
+                  <a:srgbClr val="0E2E34"/>
+                </a:solidFill>
+                <a:latin typeface="Calibri" pitchFamily="34" charset="0"/>
+                <a:ea typeface="Calibri" pitchFamily="34" charset="-122"/>
+                <a:cs typeface="Calibri" pitchFamily="34" charset="-120"/>
+              </a:rPr>
+              <a:t>Report:  "Appointments by Status" — grouped, with a chart.</a:t>
+            </a:r>
+            <a:endParaRPr lang="en-US" sz="1450" dirty="0"/>
+          </a:p>
+          <a:p>
+            <a:pPr algn="l" marL="203200" indent="-203200">
+              <a:spcAft>
+                <a:spcPts val="1300"/>
+              </a:spcAft>
+              <a:buSzPct val="100000"/>
+              <a:buChar char="•"/>
+            </a:pPr>
+            <a:r>
+              <a:rPr lang="en-US" sz="1450" dirty="0">
+                <a:solidFill>
+                  <a:srgbClr val="0E2E34"/>
+                </a:solidFill>
+                <a:latin typeface="Calibri" pitchFamily="34" charset="0"/>
+                <a:ea typeface="Calibri" pitchFamily="34" charset="-122"/>
+                <a:cs typeface="Calibri" pitchFamily="34" charset="-120"/>
+              </a:rPr>
+              <a:t>Dashboard:  "Appointments Dashboard" visualizing the data.</a:t>
+            </a:r>
+            <a:endParaRPr lang="en-US" sz="1450" dirty="0"/>
+          </a:p>
+          <a:p>
+            <a:pPr algn="l" marL="203200" indent="-203200">
+              <a:spcAft>
+                <a:spcPts val="1300"/>
+              </a:spcAft>
+              <a:buSzPct val="100000"/>
+              <a:buChar char="•"/>
+            </a:pPr>
+            <a:r>
+              <a:rPr lang="en-US" sz="1450" dirty="0">
+                <a:solidFill>
+                  <a:srgbClr val="0E2E34"/>
+                </a:solidFill>
+                <a:latin typeface="Calibri" pitchFamily="34" charset="0"/>
+                <a:ea typeface="Calibri" pitchFamily="34" charset="-122"/>
+                <a:cs typeface="Calibri" pitchFamily="34" charset="-120"/>
+              </a:rPr>
+              <a:t>Tracks Scheduled vs. Rescheduled vs. Cancelled at a glance.</a:t>
+            </a:r>
+            <a:endParaRPr lang="en-US" sz="1450" dirty="0"/>
+          </a:p>
+          <a:p>
+            <a:pPr algn="l" marL="203200" indent="-203200">
+              <a:buSzPct val="100000"/>
+              <a:buChar char="•"/>
+            </a:pPr>
+            <a:r>
+              <a:rPr lang="en-US" sz="1450" dirty="0">
+                <a:solidFill>
+                  <a:srgbClr val="0E2E34"/>
+                </a:solidFill>
+                <a:latin typeface="Calibri" pitchFamily="34" charset="0"/>
+                <a:ea typeface="Calibri" pitchFamily="34" charset="-122"/>
+                <a:cs typeface="Calibri" pitchFamily="34" charset="-120"/>
+              </a:rPr>
+              <a:t>Supports data-driven operational decisions.</a:t>
+            </a:r>
+            <a:endParaRPr lang="en-US" sz="1450" dirty="0"/>
+          </a:p>
+        </p:txBody>
+      </p:sp>
+      <p:sp>
+        <p:nvSpPr>
+          <p:cNvPr id="11" name="Text 7"/>
+          <p:cNvSpPr/>
+          <p:nvPr/>
+        </p:nvSpPr>
+        <p:spPr>
+          <a:xfrm>
+            <a:off x="6995160" y="5257800"/>
+            <a:ext cx="4617720" cy="548640"/>
+          </a:xfrm>
+          <a:prstGeom prst="rect">
+            <a:avLst/>
+          </a:prstGeom>
+          <a:noFill/>
+          <a:ln/>
+        </p:spPr>
+        <p:txBody>
+          <a:bodyPr wrap="square" rtlCol="0" anchor="ctr"/>
+          <a:lstStyle/>
+          <a:p>
+            <a:pPr algn="l" indent="0" marL="0">
+              <a:buNone/>
+            </a:pPr>
+            <a:r>
+              <a:rPr lang="en-US" sz="1150" i="1" dirty="0">
+                <a:solidFill>
+                  <a:srgbClr val="5B7079"/>
+                </a:solidFill>
+                <a:latin typeface="Calibri" pitchFamily="34" charset="0"/>
+                <a:ea typeface="Calibri" pitchFamily="34" charset="-122"/>
+                <a:cs typeface="Calibri" pitchFamily="34" charset="-120"/>
+              </a:rPr>
+              <a:t>Chart reflects status transitions validated across the three test records.</a:t>
+            </a:r>
+            <a:endParaRPr lang="en-US" sz="1150" dirty="0"/>
+          </a:p>
+        </p:txBody>
+      </p:sp>
+      <p:sp>
+        <p:nvSpPr>
+          <p:cNvPr id="12" name="Text 8"/>
+          <p:cNvSpPr/>
+          <p:nvPr/>
+        </p:nvSpPr>
+        <p:spPr>
+          <a:xfrm>
+            <a:off x="548640" y="6446520"/>
+            <a:ext cx="8229600" cy="274320"/>
+          </a:xfrm>
+          <a:prstGeom prst="rect">
+            <a:avLst/>
+          </a:prstGeom>
+          <a:noFill/>
+          <a:ln/>
+        </p:spPr>
+        <p:txBody>
+          <a:bodyPr wrap="square" rtlCol="0" anchor="ctr"/>
+          <a:lstStyle/>
+          <a:p>
+            <a:pPr algn="l" indent="0" marL="0">
+              <a:buNone/>
+            </a:pPr>
+            <a:r>
+              <a:rPr lang="en-US" sz="900" dirty="0">
+                <a:solidFill>
+                  <a:srgbClr val="5B7079"/>
+                </a:solidFill>
+                <a:latin typeface="Calibri" pitchFamily="34" charset="0"/>
+                <a:ea typeface="Calibri" pitchFamily="34" charset="-122"/>
+                <a:cs typeface="Calibri" pitchFamily="34" charset="-120"/>
+              </a:rPr>
+              <a:t>AI-Powered Appointment Management Assistant  ·  Salesforce Capstone</a:t>
+            </a:r>
+            <a:endParaRPr lang="en-US" sz="900" dirty="0"/>
+          </a:p>
+        </p:txBody>
+      </p:sp>
+    </p:spTree>
+  </p:cSld>
+  <p:clrMapOvr>
+    <a:masterClrMapping/>
+  </p:clrMapOvr>
+</p:sld>
+</file>
+
+<file path=ppt/slides/slide12.xml><?xml version="1.0" encoding="utf-8"?>
 <p:sld xmlns:a="http://schemas.openxmlformats.org/drawingml/2006/main" xmlns:r="http://schemas.openxmlformats.org/officeDocument/2006/relationships" xmlns:p="http://schemas.openxmlformats.org/presentationml/2006/main">
   <p:cSld name="Slide 10">
     <p:spTree>
@@ -2625,6 +4100,10 @@
           </a:solidFill>
           <a:ln/>
         </p:spPr>
+        <p:txBody>
+          <a:bodyPr/>
+          <a:p/>
+        </p:txBody>
       </p:sp>
       <p:pic>
         <p:nvPicPr>
@@ -2722,7 +4201,7 @@
                 <a:ea typeface="Calibri" pitchFamily="34" charset="-122"/>
                 <a:cs typeface="Calibri" pitchFamily="34" charset="-120"/>
               </a:rPr>
-              <a:t>10</a:t>
+              <a:t>12</a:t>
             </a:r>
             <a:endParaRPr lang="en-US" sz="1300" dirty="0"/>
           </a:p>
@@ -2750,6 +4229,10 @@
             <a:prstDash val="solid"/>
           </a:ln>
         </p:spPr>
+        <p:txBody>
+          <a:bodyPr/>
+          <a:p/>
+        </p:txBody>
       </p:sp>
       <p:sp>
         <p:nvSpPr>
@@ -2816,6 +4299,10 @@
             <a:prstDash val="solid"/>
           </a:ln>
         </p:spPr>
+        <p:txBody>
+          <a:bodyPr/>
+          <a:p/>
+        </p:txBody>
       </p:sp>
       <p:sp>
         <p:nvSpPr>
@@ -2838,6 +4325,10 @@
           </a:solidFill>
           <a:ln/>
         </p:spPr>
+        <p:txBody>
+          <a:bodyPr/>
+          <a:p/>
+        </p:txBody>
       </p:sp>
       <p:sp>
         <p:nvSpPr>
@@ -2986,6 +4477,10 @@
             <a:prstDash val="solid"/>
           </a:ln>
         </p:spPr>
+        <p:txBody>
+          <a:bodyPr/>
+          <a:p/>
+        </p:txBody>
       </p:sp>
       <p:sp>
         <p:nvSpPr>
@@ -3008,6 +4503,10 @@
           </a:solidFill>
           <a:ln/>
         </p:spPr>
+        <p:txBody>
+          <a:bodyPr/>
+          <a:p/>
+        </p:txBody>
       </p:sp>
       <p:sp>
         <p:nvSpPr>
@@ -3177,7 +4676,7 @@
 </p:sld>
 </file>
 
-<file path=ppt/slides/slide11.xml><?xml version="1.0" encoding="utf-8"?>
+<file path=ppt/slides/slide13.xml><?xml version="1.0" encoding="utf-8"?>
 <p:sld xmlns:a="http://schemas.openxmlformats.org/drawingml/2006/main" xmlns:r="http://schemas.openxmlformats.org/officeDocument/2006/relationships" xmlns:p="http://schemas.openxmlformats.org/presentationml/2006/main">
   <p:cSld name="Slide 11">
     <p:spTree>
@@ -3213,6 +4712,10 @@
           </a:solidFill>
           <a:ln/>
         </p:spPr>
+        <p:txBody>
+          <a:bodyPr/>
+          <a:p/>
+        </p:txBody>
       </p:sp>
       <p:pic>
         <p:nvPicPr>
@@ -3310,7 +4813,7 @@
                 <a:ea typeface="Calibri" pitchFamily="34" charset="-122"/>
                 <a:cs typeface="Calibri" pitchFamily="34" charset="-120"/>
               </a:rPr>
-              <a:t>11</a:t>
+              <a:t>13</a:t>
             </a:r>
             <a:endParaRPr lang="en-US" sz="1300" dirty="0"/>
           </a:p>
@@ -3338,6 +4841,10 @@
             <a:prstDash val="solid"/>
           </a:ln>
         </p:spPr>
+        <p:txBody>
+          <a:bodyPr/>
+          <a:p/>
+        </p:txBody>
       </p:sp>
       <p:sp>
         <p:nvSpPr>
@@ -3360,6 +4867,10 @@
           </a:solidFill>
           <a:ln/>
         </p:spPr>
+        <p:txBody>
+          <a:bodyPr/>
+          <a:p/>
+        </p:txBody>
       </p:sp>
       <p:sp>
         <p:nvSpPr>
@@ -3460,6 +4971,10 @@
           </a:solidFill>
           <a:ln/>
         </p:spPr>
+        <p:txBody>
+          <a:bodyPr/>
+          <a:p/>
+        </p:txBody>
       </p:sp>
       <p:sp>
         <p:nvSpPr>
@@ -3560,6 +5075,10 @@
           </a:solidFill>
           <a:ln/>
         </p:spPr>
+        <p:txBody>
+          <a:bodyPr/>
+          <a:p/>
+        </p:txBody>
       </p:sp>
       <p:sp>
         <p:nvSpPr>
@@ -3704,6 +5223,10 @@
             <a:prstDash val="solid"/>
           </a:ln>
         </p:spPr>
+        <p:txBody>
+          <a:bodyPr/>
+          <a:p/>
+        </p:txBody>
       </p:sp>
       <p:sp>
         <p:nvSpPr>
@@ -3770,6 +5293,10 @@
             <a:prstDash val="solid"/>
           </a:ln>
         </p:spPr>
+        <p:txBody>
+          <a:bodyPr/>
+          <a:p/>
+        </p:txBody>
       </p:sp>
       <p:sp>
         <p:nvSpPr>
@@ -3836,6 +5363,10 @@
             <a:prstDash val="solid"/>
           </a:ln>
         </p:spPr>
+        <p:txBody>
+          <a:bodyPr/>
+          <a:p/>
+        </p:txBody>
       </p:sp>
       <p:sp>
         <p:nvSpPr>
@@ -3902,6 +5433,10 @@
             <a:prstDash val="solid"/>
           </a:ln>
         </p:spPr>
+        <p:txBody>
+          <a:bodyPr/>
+          <a:p/>
+        </p:txBody>
       </p:sp>
       <p:sp>
         <p:nvSpPr>
@@ -4053,7 +5588,7 @@
 </p:sld>
 </file>
 
-<file path=ppt/slides/slide12.xml><?xml version="1.0" encoding="utf-8"?>
+<file path=ppt/slides/slide14.xml><?xml version="1.0" encoding="utf-8"?>
 <p:sld xmlns:a="http://schemas.openxmlformats.org/drawingml/2006/main" xmlns:r="http://schemas.openxmlformats.org/officeDocument/2006/relationships" xmlns:p="http://schemas.openxmlformats.org/presentationml/2006/main">
   <p:cSld name="Slide 12">
     <p:spTree>
@@ -4089,6 +5624,10 @@
           </a:solidFill>
           <a:ln/>
         </p:spPr>
+        <p:txBody>
+          <a:bodyPr/>
+          <a:p/>
+        </p:txBody>
       </p:sp>
       <p:pic>
         <p:nvPicPr>
@@ -4186,7 +5725,7 @@
                 <a:ea typeface="Calibri" pitchFamily="34" charset="-122"/>
                 <a:cs typeface="Calibri" pitchFamily="34" charset="-120"/>
               </a:rPr>
-              <a:t>12</a:t>
+              <a:t>14</a:t>
             </a:r>
             <a:endParaRPr lang="en-US" sz="1300" dirty="0"/>
           </a:p>
@@ -4214,6 +5753,10 @@
             <a:prstDash val="solid"/>
           </a:ln>
         </p:spPr>
+        <p:txBody>
+          <a:bodyPr/>
+          <a:p/>
+        </p:txBody>
       </p:sp>
       <p:sp>
         <p:nvSpPr>
@@ -4241,6 +5784,10 @@
             <a:prstDash val="solid"/>
           </a:ln>
         </p:spPr>
+        <p:txBody>
+          <a:bodyPr/>
+          <a:p/>
+        </p:txBody>
       </p:sp>
       <p:sp>
         <p:nvSpPr>
@@ -4261,6 +5808,10 @@
           </a:solidFill>
           <a:ln/>
         </p:spPr>
+        <p:txBody>
+          <a:bodyPr/>
+          <a:p/>
+        </p:txBody>
       </p:sp>
       <p:pic>
         <p:nvPicPr>
@@ -4351,6 +5902,10 @@
             <a:prstDash val="solid"/>
           </a:ln>
         </p:spPr>
+        <p:txBody>
+          <a:bodyPr/>
+          <a:p/>
+        </p:txBody>
       </p:sp>
       <p:sp>
         <p:nvSpPr>
@@ -4371,6 +5926,10 @@
           </a:solidFill>
           <a:ln/>
         </p:spPr>
+        <p:txBody>
+          <a:bodyPr/>
+          <a:p/>
+        </p:txBody>
       </p:sp>
       <p:pic>
         <p:nvPicPr>
@@ -4461,6 +6020,10 @@
             <a:prstDash val="solid"/>
           </a:ln>
         </p:spPr>
+        <p:txBody>
+          <a:bodyPr/>
+          <a:p/>
+        </p:txBody>
       </p:sp>
       <p:sp>
         <p:nvSpPr>
@@ -4481,6 +6044,10 @@
           </a:solidFill>
           <a:ln/>
         </p:spPr>
+        <p:txBody>
+          <a:bodyPr/>
+          <a:p/>
+        </p:txBody>
       </p:sp>
       <p:pic>
         <p:nvPicPr>
@@ -4571,6 +6138,10 @@
             <a:prstDash val="solid"/>
           </a:ln>
         </p:spPr>
+        <p:txBody>
+          <a:bodyPr/>
+          <a:p/>
+        </p:txBody>
       </p:sp>
       <p:sp>
         <p:nvSpPr>
@@ -4591,6 +6162,10 @@
           </a:solidFill>
           <a:ln/>
         </p:spPr>
+        <p:txBody>
+          <a:bodyPr/>
+          <a:p/>
+        </p:txBody>
       </p:sp>
       <p:pic>
         <p:nvPicPr>
@@ -4681,6 +6256,10 @@
             <a:prstDash val="solid"/>
           </a:ln>
         </p:spPr>
+        <p:txBody>
+          <a:bodyPr/>
+          <a:p/>
+        </p:txBody>
       </p:sp>
       <p:sp>
         <p:nvSpPr>
@@ -4701,6 +6280,10 @@
           </a:solidFill>
           <a:ln/>
         </p:spPr>
+        <p:txBody>
+          <a:bodyPr/>
+          <a:p/>
+        </p:txBody>
       </p:sp>
       <p:pic>
         <p:nvPicPr>
@@ -4812,7 +6395,7 @@
 </p:sld>
 </file>
 
-<file path=ppt/slides/slide13.xml><?xml version="1.0" encoding="utf-8"?>
+<file path=ppt/slides/slide15.xml><?xml version="1.0" encoding="utf-8"?>
 <p:sld xmlns:a="http://schemas.openxmlformats.org/drawingml/2006/main" xmlns:r="http://schemas.openxmlformats.org/officeDocument/2006/relationships" xmlns:p="http://schemas.openxmlformats.org/presentationml/2006/main">
   <p:cSld name="Slide 13">
     <p:bg>
@@ -4855,6 +6438,10 @@
           </a:solidFill>
           <a:ln/>
         </p:spPr>
+        <p:txBody>
+          <a:bodyPr/>
+          <a:p/>
+        </p:txBody>
       </p:sp>
       <p:sp>
         <p:nvSpPr>
@@ -4877,6 +6464,10 @@
           </a:solidFill>
           <a:ln/>
         </p:spPr>
+        <p:txBody>
+          <a:bodyPr/>
+          <a:p/>
+        </p:txBody>
       </p:sp>
       <p:pic>
         <p:nvPicPr>
@@ -5070,6 +6661,10 @@
             <a:prstDash val="solid"/>
           </a:ln>
         </p:spPr>
+        <p:txBody>
+          <a:bodyPr/>
+          <a:p/>
+        </p:txBody>
       </p:sp>
       <p:sp>
         <p:nvSpPr>
@@ -5129,6 +6724,10 @@
           </a:solidFill>
           <a:ln/>
         </p:spPr>
+        <p:txBody>
+          <a:bodyPr/>
+          <a:p/>
+        </p:txBody>
       </p:sp>
       <p:sp>
         <p:nvSpPr>
@@ -5227,6 +6826,10 @@
           </a:solidFill>
           <a:ln/>
         </p:spPr>
+        <p:txBody>
+          <a:bodyPr/>
+          <a:p/>
+        </p:txBody>
       </p:sp>
       <p:sp>
         <p:nvSpPr>
@@ -5325,6 +6928,10 @@
           </a:solidFill>
           <a:ln/>
         </p:spPr>
+        <p:txBody>
+          <a:bodyPr/>
+          <a:p/>
+        </p:txBody>
       </p:sp>
       <p:sp>
         <p:nvSpPr>
@@ -5423,6 +7030,10 @@
           </a:solidFill>
           <a:ln/>
         </p:spPr>
+        <p:txBody>
+          <a:bodyPr/>
+          <a:p/>
+        </p:txBody>
       </p:sp>
       <p:sp>
         <p:nvSpPr>
@@ -5524,6 +7135,10 @@
             <a:prstDash val="solid"/>
           </a:ln>
         </p:spPr>
+        <p:txBody>
+          <a:bodyPr/>
+          <a:p/>
+        </p:txBody>
       </p:sp>
       <p:sp>
         <p:nvSpPr>
@@ -5661,6 +7276,10 @@
           </a:solidFill>
           <a:ln/>
         </p:spPr>
+        <p:txBody>
+          <a:bodyPr/>
+          <a:p/>
+        </p:txBody>
       </p:sp>
       <p:pic>
         <p:nvPicPr>
@@ -5786,6 +7405,10 @@
             <a:prstDash val="solid"/>
           </a:ln>
         </p:spPr>
+        <p:txBody>
+          <a:bodyPr/>
+          <a:p/>
+        </p:txBody>
       </p:sp>
       <p:sp>
         <p:nvSpPr>
@@ -5955,6 +7578,10 @@
             <a:prstDash val="solid"/>
           </a:ln>
         </p:spPr>
+        <p:txBody>
+          <a:bodyPr/>
+          <a:p/>
+        </p:txBody>
       </p:sp>
       <p:sp>
         <p:nvSpPr>
@@ -6028,6 +7655,10 @@
             </a:outerShdw>
           </a:effectLst>
         </p:spPr>
+        <p:txBody>
+          <a:bodyPr/>
+          <a:p/>
+        </p:txBody>
       </p:sp>
       <p:sp>
         <p:nvSpPr>
@@ -6048,6 +7679,10 @@
           </a:solidFill>
           <a:ln/>
         </p:spPr>
+        <p:txBody>
+          <a:bodyPr/>
+          <a:p/>
+        </p:txBody>
       </p:sp>
       <p:pic>
         <p:nvPicPr>
@@ -6184,6 +7819,10 @@
             </a:outerShdw>
           </a:effectLst>
         </p:spPr>
+        <p:txBody>
+          <a:bodyPr/>
+          <a:p/>
+        </p:txBody>
       </p:sp>
       <p:sp>
         <p:nvSpPr>
@@ -6204,6 +7843,10 @@
           </a:solidFill>
           <a:ln/>
         </p:spPr>
+        <p:txBody>
+          <a:bodyPr/>
+          <a:p/>
+        </p:txBody>
       </p:sp>
       <p:pic>
         <p:nvPicPr>
@@ -6340,6 +7983,10 @@
             </a:outerShdw>
           </a:effectLst>
         </p:spPr>
+        <p:txBody>
+          <a:bodyPr/>
+          <a:p/>
+        </p:txBody>
       </p:sp>
       <p:sp>
         <p:nvSpPr>
@@ -6360,6 +8007,10 @@
           </a:solidFill>
           <a:ln/>
         </p:spPr>
+        <p:txBody>
+          <a:bodyPr/>
+          <a:p/>
+        </p:txBody>
       </p:sp>
       <p:pic>
         <p:nvPicPr>
@@ -6546,6 +8197,10 @@
           </a:solidFill>
           <a:ln/>
         </p:spPr>
+        <p:txBody>
+          <a:bodyPr/>
+          <a:p/>
+        </p:txBody>
       </p:sp>
       <p:pic>
         <p:nvPicPr>
@@ -6671,6 +8326,10 @@
             <a:prstDash val="solid"/>
           </a:ln>
         </p:spPr>
+        <p:txBody>
+          <a:bodyPr/>
+          <a:p/>
+        </p:txBody>
       </p:sp>
       <p:sp>
         <p:nvSpPr>
@@ -6698,6 +8357,10 @@
             <a:prstDash val="solid"/>
           </a:ln>
         </p:spPr>
+        <p:txBody>
+          <a:bodyPr/>
+          <a:p/>
+        </p:txBody>
       </p:sp>
       <p:sp>
         <p:nvSpPr>
@@ -6718,6 +8381,10 @@
           </a:solidFill>
           <a:ln/>
         </p:spPr>
+        <p:txBody>
+          <a:bodyPr/>
+          <a:p/>
+        </p:txBody>
       </p:sp>
       <p:sp>
         <p:nvSpPr>
@@ -6862,6 +8529,10 @@
             <a:prstDash val="solid"/>
           </a:ln>
         </p:spPr>
+        <p:txBody>
+          <a:bodyPr/>
+          <a:p/>
+        </p:txBody>
       </p:sp>
       <p:sp>
         <p:nvSpPr>
@@ -6882,6 +8553,10 @@
           </a:solidFill>
           <a:ln/>
         </p:spPr>
+        <p:txBody>
+          <a:bodyPr/>
+          <a:p/>
+        </p:txBody>
       </p:sp>
       <p:sp>
         <p:nvSpPr>
@@ -7026,6 +8701,10 @@
             <a:prstDash val="solid"/>
           </a:ln>
         </p:spPr>
+        <p:txBody>
+          <a:bodyPr/>
+          <a:p/>
+        </p:txBody>
       </p:sp>
       <p:sp>
         <p:nvSpPr>
@@ -7046,6 +8725,10 @@
           </a:solidFill>
           <a:ln/>
         </p:spPr>
+        <p:txBody>
+          <a:bodyPr/>
+          <a:p/>
+        </p:txBody>
       </p:sp>
       <p:sp>
         <p:nvSpPr>
@@ -7190,6 +8873,10 @@
             <a:prstDash val="solid"/>
           </a:ln>
         </p:spPr>
+        <p:txBody>
+          <a:bodyPr/>
+          <a:p/>
+        </p:txBody>
       </p:sp>
       <p:sp>
         <p:nvSpPr>
@@ -7210,6 +8897,10 @@
           </a:solidFill>
           <a:ln/>
         </p:spPr>
+        <p:txBody>
+          <a:bodyPr/>
+          <a:p/>
+        </p:txBody>
       </p:sp>
       <p:sp>
         <p:nvSpPr>
@@ -7322,7 +9013,7 @@
                 <a:ea typeface="Calibri" pitchFamily="34" charset="-122"/>
                 <a:cs typeface="Calibri" pitchFamily="34" charset="-120"/>
               </a:rPr>
-              <a:t>Build a Lightning App to monitor appointments.</a:t>
+              <a:t>Build a Lightning App and custom LWC for administrators.</a:t>
             </a:r>
             <a:endParaRPr lang="en-US" sz="1250" dirty="0"/>
           </a:p>
@@ -7354,6 +9045,10 @@
             <a:prstDash val="solid"/>
           </a:ln>
         </p:spPr>
+        <p:txBody>
+          <a:bodyPr/>
+          <a:p/>
+        </p:txBody>
       </p:sp>
       <p:sp>
         <p:nvSpPr>
@@ -7374,6 +9069,10 @@
           </a:solidFill>
           <a:ln/>
         </p:spPr>
+        <p:txBody>
+          <a:bodyPr/>
+          <a:p/>
+        </p:txBody>
       </p:sp>
       <p:sp>
         <p:nvSpPr>
@@ -7518,6 +9217,10 @@
             <a:prstDash val="solid"/>
           </a:ln>
         </p:spPr>
+        <p:txBody>
+          <a:bodyPr/>
+          <a:p/>
+        </p:txBody>
       </p:sp>
       <p:sp>
         <p:nvSpPr>
@@ -7538,6 +9241,10 @@
           </a:solidFill>
           <a:ln/>
         </p:spPr>
+        <p:txBody>
+          <a:bodyPr/>
+          <a:p/>
+        </p:txBody>
       </p:sp>
       <p:sp>
         <p:nvSpPr>
@@ -7739,6 +9446,10 @@
           </a:solidFill>
           <a:ln/>
         </p:spPr>
+        <p:txBody>
+          <a:bodyPr/>
+          <a:p/>
+        </p:txBody>
       </p:sp>
       <p:pic>
         <p:nvPicPr>
@@ -7864,6 +9575,10 @@
             <a:prstDash val="solid"/>
           </a:ln>
         </p:spPr>
+        <p:txBody>
+          <a:bodyPr/>
+          <a:p/>
+        </p:txBody>
       </p:sp>
       <p:sp>
         <p:nvSpPr>
@@ -7937,6 +9652,10 @@
             </a:outerShdw>
           </a:effectLst>
         </p:spPr>
+        <p:txBody>
+          <a:bodyPr/>
+          <a:p/>
+        </p:txBody>
       </p:sp>
       <p:sp>
         <p:nvSpPr>
@@ -7957,6 +9676,10 @@
           </a:solidFill>
           <a:ln/>
         </p:spPr>
+        <p:txBody>
+          <a:bodyPr/>
+          <a:p/>
+        </p:txBody>
       </p:sp>
       <p:pic>
         <p:nvPicPr>
@@ -8079,6 +9802,10 @@
           </a:solidFill>
           <a:ln/>
         </p:spPr>
+        <p:txBody>
+          <a:bodyPr/>
+          <a:p/>
+        </p:txBody>
       </p:sp>
       <p:sp>
         <p:nvSpPr>
@@ -8113,6 +9840,10 @@
             </a:outerShdw>
           </a:effectLst>
         </p:spPr>
+        <p:txBody>
+          <a:bodyPr/>
+          <a:p/>
+        </p:txBody>
       </p:sp>
       <p:sp>
         <p:nvSpPr>
@@ -8133,6 +9864,10 @@
           </a:solidFill>
           <a:ln/>
         </p:spPr>
+        <p:txBody>
+          <a:bodyPr/>
+          <a:p/>
+        </p:txBody>
       </p:sp>
       <p:pic>
         <p:nvPicPr>
@@ -8255,6 +9990,10 @@
           </a:solidFill>
           <a:ln/>
         </p:spPr>
+        <p:txBody>
+          <a:bodyPr/>
+          <a:p/>
+        </p:txBody>
       </p:sp>
       <p:sp>
         <p:nvSpPr>
@@ -8289,6 +10028,10 @@
             </a:outerShdw>
           </a:effectLst>
         </p:spPr>
+        <p:txBody>
+          <a:bodyPr/>
+          <a:p/>
+        </p:txBody>
       </p:sp>
       <p:sp>
         <p:nvSpPr>
@@ -8309,6 +10052,10 @@
           </a:solidFill>
           <a:ln/>
         </p:spPr>
+        <p:txBody>
+          <a:bodyPr/>
+          <a:p/>
+        </p:txBody>
       </p:sp>
       <p:pic>
         <p:nvPicPr>
@@ -8431,6 +10178,10 @@
           </a:solidFill>
           <a:ln/>
         </p:spPr>
+        <p:txBody>
+          <a:bodyPr/>
+          <a:p/>
+        </p:txBody>
       </p:sp>
       <p:sp>
         <p:nvSpPr>
@@ -8465,6 +10216,10 @@
             </a:outerShdw>
           </a:effectLst>
         </p:spPr>
+        <p:txBody>
+          <a:bodyPr/>
+          <a:p/>
+        </p:txBody>
       </p:sp>
       <p:sp>
         <p:nvSpPr>
@@ -8485,6 +10240,10 @@
           </a:solidFill>
           <a:ln/>
         </p:spPr>
+        <p:txBody>
+          <a:bodyPr/>
+          <a:p/>
+        </p:txBody>
       </p:sp>
       <p:pic>
         <p:nvPicPr>
@@ -8614,6 +10373,10 @@
             <a:prstDash val="solid"/>
           </a:ln>
         </p:spPr>
+        <p:txBody>
+          <a:bodyPr/>
+          <a:p/>
+        </p:txBody>
       </p:sp>
       <p:sp>
         <p:nvSpPr>
@@ -8751,6 +10514,10 @@
           </a:solidFill>
           <a:ln/>
         </p:spPr>
+        <p:txBody>
+          <a:bodyPr/>
+          <a:p/>
+        </p:txBody>
       </p:sp>
       <p:pic>
         <p:nvPicPr>
@@ -8876,6 +10643,10 @@
             <a:prstDash val="solid"/>
           </a:ln>
         </p:spPr>
+        <p:txBody>
+          <a:bodyPr/>
+          <a:p/>
+        </p:txBody>
       </p:sp>
       <p:sp>
         <p:nvSpPr>
@@ -8991,6 +10762,10 @@
             </a:outerShdw>
           </a:effectLst>
         </p:spPr>
+        <p:txBody>
+          <a:bodyPr/>
+          <a:p/>
+        </p:txBody>
       </p:sp>
       <p:sp>
         <p:nvSpPr>
@@ -9011,6 +10786,10 @@
           </a:solidFill>
           <a:ln/>
         </p:spPr>
+        <p:txBody>
+          <a:bodyPr/>
+          <a:p/>
+        </p:txBody>
       </p:sp>
       <p:sp>
         <p:nvSpPr>
@@ -9109,6 +10888,10 @@
           </a:solidFill>
           <a:ln/>
         </p:spPr>
+        <p:txBody>
+          <a:bodyPr/>
+          <a:p/>
+        </p:txBody>
       </p:sp>
       <p:sp>
         <p:nvSpPr>
@@ -9129,6 +10912,10 @@
           </a:solidFill>
           <a:ln/>
         </p:spPr>
+        <p:txBody>
+          <a:bodyPr/>
+          <a:p/>
+        </p:txBody>
       </p:sp>
       <p:sp>
         <p:nvSpPr>
@@ -9227,6 +11014,10 @@
           </a:solidFill>
           <a:ln/>
         </p:spPr>
+        <p:txBody>
+          <a:bodyPr/>
+          <a:p/>
+        </p:txBody>
       </p:sp>
       <p:sp>
         <p:nvSpPr>
@@ -9325,6 +11116,10 @@
           </a:solidFill>
           <a:ln/>
         </p:spPr>
+        <p:txBody>
+          <a:bodyPr/>
+          <a:p/>
+        </p:txBody>
       </p:sp>
       <p:sp>
         <p:nvSpPr>
@@ -9345,6 +11140,10 @@
           </a:solidFill>
           <a:ln/>
         </p:spPr>
+        <p:txBody>
+          <a:bodyPr/>
+          <a:p/>
+        </p:txBody>
       </p:sp>
       <p:sp>
         <p:nvSpPr>
@@ -9443,6 +11242,10 @@
           </a:solidFill>
           <a:ln/>
         </p:spPr>
+        <p:txBody>
+          <a:bodyPr/>
+          <a:p/>
+        </p:txBody>
       </p:sp>
       <p:sp>
         <p:nvSpPr>
@@ -9541,6 +11344,10 @@
           </a:solidFill>
           <a:ln/>
         </p:spPr>
+        <p:txBody>
+          <a:bodyPr/>
+          <a:p/>
+        </p:txBody>
       </p:sp>
       <p:sp>
         <p:nvSpPr>
@@ -9561,6 +11368,10 @@
           </a:solidFill>
           <a:ln/>
         </p:spPr>
+        <p:txBody>
+          <a:bodyPr/>
+          <a:p/>
+        </p:txBody>
       </p:sp>
       <p:sp>
         <p:nvSpPr>
@@ -9723,6 +11534,10 @@
           </a:solidFill>
           <a:ln/>
         </p:spPr>
+        <p:txBody>
+          <a:bodyPr/>
+          <a:p/>
+        </p:txBody>
       </p:sp>
       <p:pic>
         <p:nvPicPr>
@@ -9848,6 +11663,10 @@
             <a:prstDash val="solid"/>
           </a:ln>
         </p:spPr>
+        <p:txBody>
+          <a:bodyPr/>
+          <a:p/>
+        </p:txBody>
       </p:sp>
       <p:sp>
         <p:nvSpPr>
@@ -9882,6 +11701,10 @@
             </a:outerShdw>
           </a:effectLst>
         </p:spPr>
+        <p:txBody>
+          <a:bodyPr/>
+          <a:p/>
+        </p:txBody>
       </p:sp>
       <p:sp>
         <p:nvSpPr>
@@ -9904,6 +11727,10 @@
           </a:solidFill>
           <a:ln/>
         </p:spPr>
+        <p:txBody>
+          <a:bodyPr/>
+          <a:p/>
+        </p:txBody>
       </p:sp>
       <p:sp>
         <p:nvSpPr>
@@ -9924,6 +11751,10 @@
           </a:solidFill>
           <a:ln/>
         </p:spPr>
+        <p:txBody>
+          <a:bodyPr/>
+          <a:p/>
+        </p:txBody>
       </p:sp>
       <p:pic>
         <p:nvPicPr>
@@ -10132,6 +11963,10 @@
             </a:outerShdw>
           </a:effectLst>
         </p:spPr>
+        <p:txBody>
+          <a:bodyPr/>
+          <a:p/>
+        </p:txBody>
       </p:sp>
       <p:sp>
         <p:nvSpPr>
@@ -10154,6 +11989,10 @@
           </a:solidFill>
           <a:ln/>
         </p:spPr>
+        <p:txBody>
+          <a:bodyPr/>
+          <a:p/>
+        </p:txBody>
       </p:sp>
       <p:sp>
         <p:nvSpPr>
@@ -10174,6 +12013,10 @@
           </a:solidFill>
           <a:ln/>
         </p:spPr>
+        <p:txBody>
+          <a:bodyPr/>
+          <a:p/>
+        </p:txBody>
       </p:sp>
       <p:pic>
         <p:nvPicPr>
@@ -10382,6 +12225,10 @@
             </a:outerShdw>
           </a:effectLst>
         </p:spPr>
+        <p:txBody>
+          <a:bodyPr/>
+          <a:p/>
+        </p:txBody>
       </p:sp>
       <p:sp>
         <p:nvSpPr>
@@ -10404,6 +12251,10 @@
           </a:solidFill>
           <a:ln/>
         </p:spPr>
+        <p:txBody>
+          <a:bodyPr/>
+          <a:p/>
+        </p:txBody>
       </p:sp>
       <p:sp>
         <p:nvSpPr>
@@ -10424,6 +12275,10 @@
           </a:solidFill>
           <a:ln/>
         </p:spPr>
+        <p:txBody>
+          <a:bodyPr/>
+          <a:p/>
+        </p:txBody>
       </p:sp>
       <p:pic>
         <p:nvPicPr>
@@ -10609,6 +12464,10 @@
           </a:solidFill>
           <a:ln/>
         </p:spPr>
+        <p:txBody>
+          <a:bodyPr/>
+          <a:p/>
+        </p:txBody>
       </p:sp>
       <p:sp>
         <p:nvSpPr>
@@ -10711,6 +12570,632 @@
 </file>
 
 <file path=ppt/slides/slide7.xml><?xml version="1.0" encoding="utf-8"?>
+<p:sld xmlns:a="http://schemas.openxmlformats.org/drawingml/2006/main" xmlns:p="http://schemas.openxmlformats.org/presentationml/2006/main" xmlns:r="http://schemas.openxmlformats.org/officeDocument/2006/relationships">
+  <p:cSld>
+    <p:spTree>
+      <p:nvGrpSpPr>
+        <p:cNvPr id="1" name=""/>
+        <p:cNvGrpSpPr/>
+        <p:nvPr/>
+      </p:nvGrpSpPr>
+      <p:grpSpPr/>
+      <p:sp>
+        <p:nvSpPr>
+          <p:cNvPr id="2" name="Shape 0"/>
+          <p:cNvSpPr/>
+          <p:nvPr/>
+        </p:nvSpPr>
+        <p:spPr>
+          <a:xfrm>
+            <a:off x="548640" y="475488"/>
+            <a:ext cx="585216" cy="585216"/>
+          </a:xfrm>
+          <a:prstGeom prst="ellipse">
+            <a:avLst/>
+          </a:prstGeom>
+          <a:solidFill>
+            <a:srgbClr val="028090"/>
+          </a:solidFill>
+          <a:ln/>
+        </p:spPr>
+        <p:txBody>
+          <a:bodyPr/>
+          <a:p/>
+        </p:txBody>
+      </p:sp>
+      <p:pic>
+        <p:nvPicPr>
+          <p:cNvPr id="3" name="Image 0" descr="preencoded.png">    </p:cNvPr>
+          <p:cNvPicPr>
+            <a:picLocks noChangeAspect="1"/>
+          </p:cNvPicPr>
+          <p:nvPr/>
+        </p:nvPicPr>
+        <p:blipFill>
+          <a:blip r:embed="rId2"/>
+          <a:stretch>
+            <a:fillRect/>
+          </a:stretch>
+        </p:blipFill>
+        <p:spPr>
+          <a:xfrm>
+            <a:off x="694944" y="621792"/>
+            <a:ext cx="292608" cy="292608"/>
+          </a:xfrm>
+          <a:prstGeom prst="rect">
+            <a:avLst/>
+          </a:prstGeom>
+        </p:spPr>
+      </p:pic>
+      <p:sp>
+        <p:nvSpPr>
+          <p:cNvPr id="4" name="Text 1"/>
+          <p:cNvSpPr/>
+          <p:nvPr/>
+        </p:nvSpPr>
+        <p:spPr>
+          <a:xfrm>
+            <a:off x="1335024" y="457200"/>
+            <a:ext cx="10030968" cy="621792"/>
+          </a:xfrm>
+          <a:prstGeom prst="rect">
+            <a:avLst/>
+          </a:prstGeom>
+          <a:noFill/>
+          <a:ln/>
+        </p:spPr>
+        <p:txBody>
+          <a:bodyPr wrap="square" lIns="0" tIns="0" rIns="0" bIns="0" rtlCol="0" anchor="ctr"/>
+          <a:lstStyle/>
+          <a:p>
+            <a:pPr algn="l" indent="0" marL="0">
+              <a:buNone/>
+            </a:pPr>
+            <a:r>
+              <a:rPr lang="en-US" sz="3000" b="1" dirty="0">
+                <a:solidFill>
+                  <a:srgbClr val="0E2E34"/>
+                </a:solidFill>
+                <a:latin typeface="Cambria" pitchFamily="34" charset="0"/>
+                <a:ea typeface="Cambria" pitchFamily="34" charset="-122"/>
+                <a:cs typeface="Cambria" pitchFamily="34" charset="-120"/>
+              </a:rPr>
+              <a:t>Invocable Apex Action — the Agent Bridge</a:t>
+            </a:r>
+            <a:endParaRPr lang="en-US" sz="3000" dirty="0"/>
+          </a:p>
+        </p:txBody>
+      </p:sp>
+      <p:sp>
+        <p:nvSpPr>
+          <p:cNvPr id="5" name="Text 2"/>
+          <p:cNvSpPr/>
+          <p:nvPr/>
+        </p:nvSpPr>
+        <p:spPr>
+          <a:xfrm>
+            <a:off x="11183112" y="502920"/>
+            <a:ext cx="457200" cy="530352"/>
+          </a:xfrm>
+          <a:prstGeom prst="rect">
+            <a:avLst/>
+          </a:prstGeom>
+          <a:noFill/>
+          <a:ln/>
+        </p:spPr>
+        <p:txBody>
+          <a:bodyPr wrap="square" rtlCol="0" anchor="ctr"/>
+          <a:lstStyle/>
+          <a:p>
+            <a:pPr algn="r" indent="0" marL="0">
+              <a:buNone/>
+            </a:pPr>
+            <a:r>
+              <a:rPr lang="en-US" sz="1300" b="1" dirty="0">
+                <a:solidFill>
+                  <a:srgbClr val="5B7079"/>
+                </a:solidFill>
+                <a:latin typeface="Calibri" pitchFamily="34" charset="0"/>
+                <a:ea typeface="Calibri" pitchFamily="34" charset="-122"/>
+                <a:cs typeface="Calibri" pitchFamily="34" charset="-120"/>
+              </a:rPr>
+              <a:t>7</a:t>
+            </a:r>
+            <a:endParaRPr lang="en-US" sz="1300" dirty="0"/>
+          </a:p>
+        </p:txBody>
+      </p:sp>
+      <p:sp>
+        <p:nvSpPr>
+          <p:cNvPr id="6" name="Shape 3"/>
+          <p:cNvSpPr/>
+          <p:nvPr/>
+        </p:nvSpPr>
+        <p:spPr>
+          <a:xfrm>
+            <a:off x="548640" y="1261872"/>
+            <a:ext cx="1005840" cy="0"/>
+          </a:xfrm>
+          <a:prstGeom prst="line">
+            <a:avLst/>
+          </a:prstGeom>
+          <a:noFill/>
+          <a:ln w="31750">
+            <a:solidFill>
+              <a:srgbClr val="02C39A"/>
+            </a:solidFill>
+            <a:prstDash val="solid"/>
+          </a:ln>
+        </p:spPr>
+        <p:txBody>
+          <a:bodyPr/>
+          <a:p/>
+        </p:txBody>
+      </p:sp>
+      <p:sp>
+        <p:nvSpPr>
+          <p:cNvPr id="7" name="Text 4"/>
+          <p:cNvSpPr/>
+          <p:nvPr/>
+        </p:nvSpPr>
+        <p:spPr>
+          <a:xfrm>
+            <a:off x="548640" y="1417320"/>
+            <a:ext cx="11064240" cy="640080"/>
+          </a:xfrm>
+          <a:prstGeom prst="rect">
+            <a:avLst/>
+          </a:prstGeom>
+          <a:noFill/>
+          <a:ln/>
+        </p:spPr>
+        <p:txBody>
+          <a:bodyPr wrap="square" rtlCol="0" anchor="ctr"/>
+          <a:lstStyle/>
+          <a:p>
+            <a:pPr algn="l" indent="0" marL="0">
+              <a:buNone/>
+            </a:pPr>
+            <a:r>
+              <a:rPr lang="en-US" sz="1400" dirty="0">
+                <a:solidFill>
+                  <a:srgbClr val="5B7079"/>
+                </a:solidFill>
+                <a:latin typeface="Calibri" pitchFamily="34" charset="0"/>
+                <a:ea typeface="Calibri" pitchFamily="34" charset="-122"/>
+                <a:cs typeface="Calibri" pitchFamily="34" charset="-120"/>
+              </a:rPr>
+              <a:t>One @InvocableMethod appears in both the Flow palette and the Agentforce action library — so the agent and the user interface share one implementation, with no wrapper in between.</a:t>
+            </a:r>
+            <a:endParaRPr lang="en-US" sz="1400" dirty="0"/>
+          </a:p>
+        </p:txBody>
+      </p:sp>
+      <p:sp>
+        <p:nvSpPr>
+          <p:cNvPr id="8" name="Shape 5"/>
+          <p:cNvSpPr/>
+          <p:nvPr/>
+        </p:nvSpPr>
+        <p:spPr>
+          <a:xfrm>
+            <a:off x="548640" y="2194560"/>
+            <a:ext cx="5362956" cy="3566160"/>
+          </a:xfrm>
+          <a:prstGeom prst="roundRect">
+            <a:avLst>
+              <a:gd name="adj" fmla="val 3077"/>
+            </a:avLst>
+          </a:prstGeom>
+          <a:solidFill>
+            <a:srgbClr val="FFFFFF"/>
+          </a:solidFill>
+          <a:ln w="15875">
+            <a:solidFill>
+              <a:srgbClr val="D5E2E4"/>
+            </a:solidFill>
+            <a:prstDash val="solid"/>
+          </a:ln>
+        </p:spPr>
+        <p:txBody>
+          <a:bodyPr/>
+          <a:p/>
+        </p:txBody>
+      </p:sp>
+      <p:sp>
+        <p:nvSpPr>
+          <p:cNvPr id="9" name="Shape 6"/>
+          <p:cNvSpPr/>
+          <p:nvPr/>
+        </p:nvSpPr>
+        <p:spPr>
+          <a:xfrm>
+            <a:off x="548640" y="2194560"/>
+            <a:ext cx="5362956" cy="640080"/>
+          </a:xfrm>
+          <a:prstGeom prst="roundRect">
+            <a:avLst>
+              <a:gd name="adj" fmla="val 17143"/>
+            </a:avLst>
+          </a:prstGeom>
+          <a:solidFill>
+            <a:srgbClr val="E0A02F"/>
+          </a:solidFill>
+          <a:ln/>
+        </p:spPr>
+        <p:txBody>
+          <a:bodyPr/>
+          <a:p/>
+        </p:txBody>
+      </p:sp>
+      <p:sp>
+        <p:nvSpPr>
+          <p:cNvPr id="10" name="Text 7"/>
+          <p:cNvSpPr/>
+          <p:nvPr/>
+        </p:nvSpPr>
+        <p:spPr>
+          <a:xfrm>
+            <a:off x="822960" y="2194560"/>
+            <a:ext cx="4814316" cy="640080"/>
+          </a:xfrm>
+          <a:prstGeom prst="rect">
+            <a:avLst/>
+          </a:prstGeom>
+          <a:noFill/>
+          <a:ln/>
+        </p:spPr>
+        <p:txBody>
+          <a:bodyPr wrap="square" rtlCol="0" anchor="ctr"/>
+          <a:lstStyle/>
+          <a:p>
+            <a:pPr algn="l" indent="0" marL="0">
+              <a:buNone/>
+            </a:pPr>
+            <a:r>
+              <a:rPr lang="en-US" sz="1600" b="1" dirty="0">
+                <a:solidFill>
+                  <a:srgbClr val="FFFFFF"/>
+                </a:solidFill>
+                <a:latin typeface="Calibri" pitchFamily="34" charset="0"/>
+                <a:ea typeface="Calibri" pitchFamily="34" charset="-122"/>
+                <a:cs typeface="Calibri" pitchFamily="34" charset="-120"/>
+              </a:rPr>
+              <a:t>Four Operations</a:t>
+            </a:r>
+            <a:endParaRPr lang="en-US" sz="1600" dirty="0"/>
+          </a:p>
+        </p:txBody>
+      </p:sp>
+      <p:sp>
+        <p:nvSpPr>
+          <p:cNvPr id="11" name="Text 8"/>
+          <p:cNvSpPr/>
+          <p:nvPr/>
+        </p:nvSpPr>
+        <p:spPr>
+          <a:xfrm>
+            <a:off x="822960" y="3063240"/>
+            <a:ext cx="4814316" cy="2560320"/>
+          </a:xfrm>
+          <a:prstGeom prst="rect">
+            <a:avLst/>
+          </a:prstGeom>
+          <a:noFill/>
+          <a:ln/>
+        </p:spPr>
+        <p:txBody>
+          <a:bodyPr wrap="square" rtlCol="0" anchor="t"/>
+          <a:lstStyle/>
+          <a:p>
+            <a:pPr algn="l" marL="203200" indent="-203200">
+              <a:spcAft>
+                <a:spcPts val="1200"/>
+              </a:spcAft>
+              <a:buSzPct val="100000"/>
+              <a:buChar char="•"/>
+            </a:pPr>
+            <a:r>
+              <a:rPr lang="en-US" sz="1400" dirty="0">
+                <a:solidFill>
+                  <a:srgbClr val="0E2E34"/>
+                </a:solidFill>
+                <a:latin typeface="Calibri" pitchFamily="34" charset="0"/>
+                <a:ea typeface="Calibri" pitchFamily="34" charset="-122"/>
+                <a:cs typeface="Calibri" pitchFamily="34" charset="-120"/>
+              </a:rPr>
+              <a:t>create — validates the inputs, then inserts it as Scheduled.</a:t>
+            </a:r>
+            <a:endParaRPr lang="en-US" sz="1400" dirty="0"/>
+          </a:p>
+          <a:p>
+            <a:pPr algn="l" marL="203200" indent="-203200">
+              <a:spcAft>
+                <a:spcPts val="1200"/>
+              </a:spcAft>
+              <a:buSzPct val="100000"/>
+              <a:buChar char="•"/>
+            </a:pPr>
+            <a:r>
+              <a:rPr lang="en-US" sz="1400" dirty="0">
+                <a:solidFill>
+                  <a:srgbClr val="0E2E34"/>
+                </a:solidFill>
+                <a:latin typeface="Calibri" pitchFamily="34" charset="0"/>
+                <a:ea typeface="Calibri" pitchFamily="34" charset="-122"/>
+                <a:cs typeface="Calibri" pitchFamily="34" charset="-120"/>
+              </a:rPr>
+              <a:t>reschedule — moves it and sets Status = Rescheduled.</a:t>
+            </a:r>
+            <a:endParaRPr lang="en-US" sz="1400" dirty="0"/>
+          </a:p>
+          <a:p>
+            <a:pPr algn="l" marL="203200" indent="-203200">
+              <a:spcAft>
+                <a:spcPts val="1200"/>
+              </a:spcAft>
+              <a:buSzPct val="100000"/>
+              <a:buChar char="•"/>
+            </a:pPr>
+            <a:r>
+              <a:rPr lang="en-US" sz="1400" dirty="0">
+                <a:solidFill>
+                  <a:srgbClr val="0E2E34"/>
+                </a:solidFill>
+                <a:latin typeface="Calibri" pitchFamily="34" charset="0"/>
+                <a:ea typeface="Calibri" pitchFamily="34" charset="-122"/>
+                <a:cs typeface="Calibri" pitchFamily="34" charset="-120"/>
+              </a:rPr>
+              <a:t>cancel — sets Status = Cancelled; the record is kept.</a:t>
+            </a:r>
+            <a:endParaRPr lang="en-US" sz="1400" dirty="0"/>
+          </a:p>
+          <a:p>
+            <a:pPr algn="l" marL="203200" indent="-203200">
+              <a:buSzPct val="100000"/>
+              <a:buChar char="•"/>
+            </a:pPr>
+            <a:r>
+              <a:rPr lang="en-US" sz="1400" dirty="0">
+                <a:solidFill>
+                  <a:srgbClr val="0E2E34"/>
+                </a:solidFill>
+                <a:latin typeface="Calibri" pitchFamily="34" charset="0"/>
+                <a:ea typeface="Calibri" pitchFamily="34" charset="-122"/>
+                <a:cs typeface="Calibri" pitchFamily="34" charset="-120"/>
+              </a:rPr>
+              <a:t>list — reads the customer’s real appointments back.</a:t>
+            </a:r>
+            <a:endParaRPr lang="en-US" sz="1400" dirty="0"/>
+          </a:p>
+        </p:txBody>
+      </p:sp>
+      <p:sp>
+        <p:nvSpPr>
+          <p:cNvPr id="12" name="Shape 9"/>
+          <p:cNvSpPr/>
+          <p:nvPr/>
+        </p:nvSpPr>
+        <p:spPr>
+          <a:xfrm>
+            <a:off x="6277356" y="2194560"/>
+            <a:ext cx="5362956" cy="3566160"/>
+          </a:xfrm>
+          <a:prstGeom prst="roundRect">
+            <a:avLst>
+              <a:gd name="adj" fmla="val 3077"/>
+            </a:avLst>
+          </a:prstGeom>
+          <a:solidFill>
+            <a:srgbClr val="FFFFFF"/>
+          </a:solidFill>
+          <a:ln w="15875">
+            <a:solidFill>
+              <a:srgbClr val="D5E2E4"/>
+            </a:solidFill>
+            <a:prstDash val="solid"/>
+          </a:ln>
+        </p:spPr>
+        <p:txBody>
+          <a:bodyPr/>
+          <a:p/>
+        </p:txBody>
+      </p:sp>
+      <p:sp>
+        <p:nvSpPr>
+          <p:cNvPr id="13" name="Shape 10"/>
+          <p:cNvSpPr/>
+          <p:nvPr/>
+        </p:nvSpPr>
+        <p:spPr>
+          <a:xfrm>
+            <a:off x="6277356" y="2194560"/>
+            <a:ext cx="5362956" cy="640080"/>
+          </a:xfrm>
+          <a:prstGeom prst="roundRect">
+            <a:avLst>
+              <a:gd name="adj" fmla="val 17143"/>
+            </a:avLst>
+          </a:prstGeom>
+          <a:solidFill>
+            <a:srgbClr val="00A896"/>
+          </a:solidFill>
+          <a:ln/>
+        </p:spPr>
+        <p:txBody>
+          <a:bodyPr/>
+          <a:p/>
+        </p:txBody>
+      </p:sp>
+      <p:sp>
+        <p:nvSpPr>
+          <p:cNvPr id="14" name="Text 11"/>
+          <p:cNvSpPr/>
+          <p:nvPr/>
+        </p:nvSpPr>
+        <p:spPr>
+          <a:xfrm>
+            <a:off x="6551676" y="2194560"/>
+            <a:ext cx="4814316" cy="640080"/>
+          </a:xfrm>
+          <a:prstGeom prst="rect">
+            <a:avLst/>
+          </a:prstGeom>
+          <a:noFill/>
+          <a:ln/>
+        </p:spPr>
+        <p:txBody>
+          <a:bodyPr wrap="square" rtlCol="0" anchor="ctr"/>
+          <a:lstStyle/>
+          <a:p>
+            <a:pPr algn="l" indent="0" marL="0">
+              <a:buNone/>
+            </a:pPr>
+            <a:r>
+              <a:rPr lang="en-US" sz="1600" b="1" dirty="0">
+                <a:solidFill>
+                  <a:srgbClr val="FFFFFF"/>
+                </a:solidFill>
+                <a:latin typeface="Calibri" pitchFamily="34" charset="0"/>
+                <a:ea typeface="Calibri" pitchFamily="34" charset="-122"/>
+                <a:cs typeface="Calibri" pitchFamily="34" charset="-120"/>
+              </a:rPr>
+              <a:t>Safe to Hand an Agent</a:t>
+            </a:r>
+            <a:endParaRPr lang="en-US" sz="1600" dirty="0"/>
+          </a:p>
+        </p:txBody>
+      </p:sp>
+      <p:sp>
+        <p:nvSpPr>
+          <p:cNvPr id="15" name="Text 12"/>
+          <p:cNvSpPr/>
+          <p:nvPr/>
+        </p:nvSpPr>
+        <p:spPr>
+          <a:xfrm>
+            <a:off x="6551676" y="3063240"/>
+            <a:ext cx="4814316" cy="2560320"/>
+          </a:xfrm>
+          <a:prstGeom prst="rect">
+            <a:avLst/>
+          </a:prstGeom>
+          <a:noFill/>
+          <a:ln/>
+        </p:spPr>
+        <p:txBody>
+          <a:bodyPr wrap="square" rtlCol="0" anchor="t"/>
+          <a:lstStyle/>
+          <a:p>
+            <a:pPr algn="l" marL="203200" indent="-203200">
+              <a:spcAft>
+                <a:spcPts val="1200"/>
+              </a:spcAft>
+              <a:buSzPct val="100000"/>
+              <a:buChar char="•"/>
+            </a:pPr>
+            <a:r>
+              <a:rPr lang="en-US" sz="1400" dirty="0">
+                <a:solidFill>
+                  <a:srgbClr val="0E2E34"/>
+                </a:solidFill>
+                <a:latin typeface="Calibri" pitchFamily="34" charset="0"/>
+                <a:ea typeface="Calibri" pitchFamily="34" charset="-122"/>
+                <a:cs typeface="Calibri" pitchFamily="34" charset="-120"/>
+              </a:rPr>
+              <a:t>Every query and DML runs in USER_MODE — the platform enforces the user’s access.</a:t>
+            </a:r>
+            <a:endParaRPr lang="en-US" sz="1400" dirty="0"/>
+          </a:p>
+          <a:p>
+            <a:pPr algn="l" marL="203200" indent="-203200">
+              <a:spcAft>
+                <a:spcPts val="1200"/>
+              </a:spcAft>
+              <a:buSzPct val="100000"/>
+              <a:buChar char="•"/>
+            </a:pPr>
+            <a:r>
+              <a:rPr lang="en-US" sz="1400" dirty="0">
+                <a:solidFill>
+                  <a:srgbClr val="0E2E34"/>
+                </a:solidFill>
+                <a:latin typeface="Calibri" pitchFamily="34" charset="0"/>
+                <a:ea typeface="Calibri" pitchFamily="34" charset="-122"/>
+                <a:cs typeface="Calibri" pitchFamily="34" charset="-120"/>
+              </a:rPr>
+              <a:t>Never throws: every failure returns a plain-language message, so a conversation stays recoverable.</a:t>
+            </a:r>
+            <a:endParaRPr lang="en-US" sz="1400" dirty="0"/>
+          </a:p>
+          <a:p>
+            <a:pPr algn="l" marL="203200" indent="-203200">
+              <a:buSzPct val="100000"/>
+              <a:buChar char="•"/>
+            </a:pPr>
+            <a:r>
+              <a:rPr lang="en-US" sz="1400" dirty="0">
+                <a:solidFill>
+                  <a:srgbClr val="0E2E34"/>
+                </a:solidFill>
+                <a:latin typeface="Calibri" pitchFamily="34" charset="0"/>
+                <a:ea typeface="Calibri" pitchFamily="34" charset="-122"/>
+                <a:cs typeface="Calibri" pitchFamily="34" charset="-120"/>
+              </a:rPr>
+              <a:t>Bulkified by construction, and covered by 14 Apex tests.</a:t>
+            </a:r>
+            <a:endParaRPr lang="en-US" sz="1400" dirty="0"/>
+          </a:p>
+        </p:txBody>
+      </p:sp>
+      <p:sp>
+        <p:nvSpPr>
+          <p:cNvPr id="16" name="Text 13"/>
+          <p:cNvSpPr/>
+          <p:nvPr/>
+        </p:nvSpPr>
+        <p:spPr>
+          <a:xfrm>
+            <a:off x="548640" y="6446520"/>
+            <a:ext cx="8229600" cy="274320"/>
+          </a:xfrm>
+          <a:prstGeom prst="rect">
+            <a:avLst/>
+          </a:prstGeom>
+          <a:noFill/>
+          <a:ln/>
+        </p:spPr>
+        <p:txBody>
+          <a:bodyPr wrap="square" rtlCol="0" anchor="ctr"/>
+          <a:lstStyle/>
+          <a:p>
+            <a:pPr algn="l" indent="0" marL="0">
+              <a:buNone/>
+            </a:pPr>
+            <a:r>
+              <a:rPr lang="en-US" sz="900" dirty="0">
+                <a:solidFill>
+                  <a:srgbClr val="5B7079"/>
+                </a:solidFill>
+                <a:latin typeface="Calibri" pitchFamily="34" charset="0"/>
+                <a:ea typeface="Calibri" pitchFamily="34" charset="-122"/>
+                <a:cs typeface="Calibri" pitchFamily="34" charset="-120"/>
+              </a:rPr>
+              <a:t>AI-Powered Appointment Management Assistant  ·  Salesforce Capstone</a:t>
+            </a:r>
+            <a:endParaRPr lang="en-US" sz="900" dirty="0"/>
+          </a:p>
+        </p:txBody>
+      </p:sp>
+    </p:spTree>
+  </p:cSld>
+  <p:clrMapOvr>
+    <a:masterClrMapping/>
+  </p:clrMapOvr>
+</p:sld>
+</file>
+
+<file path=ppt/slides/slide8.xml><?xml version="1.0" encoding="utf-8"?>
 <p:sld xmlns:a="http://schemas.openxmlformats.org/drawingml/2006/main" xmlns:r="http://schemas.openxmlformats.org/officeDocument/2006/relationships" xmlns:p="http://schemas.openxmlformats.org/presentationml/2006/main">
   <p:cSld name="Slide 7">
     <p:spTree>
@@ -10746,6 +13231,10 @@
           </a:solidFill>
           <a:ln/>
         </p:spPr>
+        <p:txBody>
+          <a:bodyPr/>
+          <a:p/>
+        </p:txBody>
       </p:sp>
       <p:pic>
         <p:nvPicPr>
@@ -10843,7 +13332,7 @@
                 <a:ea typeface="Calibri" pitchFamily="34" charset="-122"/>
                 <a:cs typeface="Calibri" pitchFamily="34" charset="-120"/>
               </a:rPr>
-              <a:t>7</a:t>
+              <a:t>8</a:t>
             </a:r>
             <a:endParaRPr lang="en-US" sz="1300" dirty="0"/>
           </a:p>
@@ -10871,6 +13360,10 @@
             <a:prstDash val="solid"/>
           </a:ln>
         </p:spPr>
+        <p:txBody>
+          <a:bodyPr/>
+          <a:p/>
+        </p:txBody>
       </p:sp>
       <p:sp>
         <p:nvSpPr>
@@ -10905,6 +13398,10 @@
             </a:outerShdw>
           </a:effectLst>
         </p:spPr>
+        <p:txBody>
+          <a:bodyPr/>
+          <a:p/>
+        </p:txBody>
       </p:sp>
       <p:sp>
         <p:nvSpPr>
@@ -10927,6 +13424,10 @@
           </a:solidFill>
           <a:ln/>
         </p:spPr>
+        <p:txBody>
+          <a:bodyPr/>
+          <a:p/>
+        </p:txBody>
       </p:sp>
       <p:sp>
         <p:nvSpPr>
@@ -11032,6 +13533,10 @@
             <a:prstDash val="solid"/>
           </a:ln>
         </p:spPr>
+        <p:txBody>
+          <a:bodyPr/>
+          <a:p/>
+        </p:txBody>
       </p:sp>
       <p:sp>
         <p:nvSpPr>
@@ -11137,6 +13642,10 @@
             <a:prstDash val="solid"/>
           </a:ln>
         </p:spPr>
+        <p:txBody>
+          <a:bodyPr/>
+          <a:p/>
+        </p:txBody>
       </p:sp>
       <p:sp>
         <p:nvSpPr>
@@ -11237,6 +13746,10 @@
           </a:solidFill>
           <a:ln/>
         </p:spPr>
+        <p:txBody>
+          <a:bodyPr/>
+          <a:p/>
+        </p:txBody>
       </p:sp>
       <p:sp>
         <p:nvSpPr>
@@ -11487,23 +14000,16 @@
 </p:sld>
 </file>
 
-<file path=ppt/slides/slide8.xml><?xml version="1.0" encoding="utf-8"?>
-<p:sld xmlns:a="http://schemas.openxmlformats.org/drawingml/2006/main" xmlns:r="http://schemas.openxmlformats.org/officeDocument/2006/relationships" xmlns:p="http://schemas.openxmlformats.org/presentationml/2006/main">
-  <p:cSld name="Slide 8">
+<file path=ppt/slides/slide9.xml><?xml version="1.0" encoding="utf-8"?>
+<p:sld xmlns:a="http://schemas.openxmlformats.org/drawingml/2006/main" xmlns:p="http://schemas.openxmlformats.org/presentationml/2006/main" xmlns:r="http://schemas.openxmlformats.org/officeDocument/2006/relationships">
+  <p:cSld>
     <p:spTree>
       <p:nvGrpSpPr>
         <p:cNvPr id="1" name=""/>
         <p:cNvGrpSpPr/>
         <p:nvPr/>
       </p:nvGrpSpPr>
-      <p:grpSpPr>
-        <a:xfrm>
-          <a:off x="0" y="0"/>
-          <a:ext cx="0" cy="0"/>
-          <a:chOff x="0" y="0"/>
-          <a:chExt cx="0" cy="0"/>
-        </a:xfrm>
-      </p:grpSpPr>
+      <p:grpSpPr/>
       <p:sp>
         <p:nvSpPr>
           <p:cNvPr id="2" name="Shape 0"/>
@@ -11523,6 +14029,10 @@
           </a:solidFill>
           <a:ln/>
         </p:spPr>
+        <p:txBody>
+          <a:bodyPr/>
+          <a:p/>
+        </p:txBody>
       </p:sp>
       <p:pic>
         <p:nvPicPr>
@@ -11533,7 +14043,7 @@
           <p:nvPr/>
         </p:nvPicPr>
         <p:blipFill>
-          <a:blip r:embed="rId1"/>
+          <a:blip r:embed="rId2"/>
           <a:stretch>
             <a:fillRect/>
           </a:stretch>
@@ -11581,7 +14091,7 @@
                 <a:ea typeface="Cambria" pitchFamily="34" charset="-122"/>
                 <a:cs typeface="Cambria" pitchFamily="34" charset="-120"/>
               </a:rPr>
-              <a:t>Lightning App</a:t>
+              <a:t>Custom Lightning Web Component</a:t>
             </a:r>
             <a:endParaRPr lang="en-US" sz="3000" dirty="0"/>
           </a:p>
@@ -11620,7 +14130,7 @@
                 <a:ea typeface="Calibri" pitchFamily="34" charset="-122"/>
                 <a:cs typeface="Calibri" pitchFamily="34" charset="-120"/>
               </a:rPr>
-              <a:t>8</a:t>
+              <a:t>9</a:t>
             </a:r>
             <a:endParaRPr lang="en-US" sz="1300" dirty="0"/>
           </a:p>
@@ -11648,21 +14158,64 @@
             <a:prstDash val="solid"/>
           </a:ln>
         </p:spPr>
-      </p:sp>
-      <p:sp>
-        <p:nvSpPr>
-          <p:cNvPr id="7" name="Shape 4"/>
-          <p:cNvSpPr/>
-          <p:nvPr/>
-        </p:nvSpPr>
-        <p:spPr>
-          <a:xfrm>
-            <a:off x="548640" y="1691640"/>
-            <a:ext cx="6309360" cy="3840480"/>
+        <p:txBody>
+          <a:bodyPr/>
+          <a:p/>
+        </p:txBody>
+      </p:sp>
+      <p:sp>
+        <p:nvSpPr>
+          <p:cNvPr id="7" name="Text 4"/>
+          <p:cNvSpPr/>
+          <p:nvPr/>
+        </p:nvSpPr>
+        <p:spPr>
+          <a:xfrm>
+            <a:off x="548640" y="1417320"/>
+            <a:ext cx="11064240" cy="640080"/>
+          </a:xfrm>
+          <a:prstGeom prst="rect">
+            <a:avLst/>
+          </a:prstGeom>
+          <a:noFill/>
+          <a:ln/>
+        </p:spPr>
+        <p:txBody>
+          <a:bodyPr wrap="square" rtlCol="0" anchor="ctr"/>
+          <a:lstStyle/>
+          <a:p>
+            <a:pPr algn="l" indent="0" marL="0">
+              <a:buNone/>
+            </a:pPr>
+            <a:r>
+              <a:rPr lang="en-US" sz="1400" dirty="0">
+                <a:solidFill>
+                  <a:srgbClr val="5B7079"/>
+                </a:solidFill>
+                <a:latin typeface="Calibri" pitchFamily="34" charset="0"/>
+                <a:ea typeface="Calibri" pitchFamily="34" charset="-122"/>
+                <a:cs typeface="Calibri" pitchFamily="34" charset="-120"/>
+              </a:rPr>
+              <a:t>“Upcoming Appointments” — a custom LWC on the app Home page, backed by a security-enforced Apex controller.</a:t>
+            </a:r>
+            <a:endParaRPr lang="en-US" sz="1400" dirty="0"/>
+          </a:p>
+        </p:txBody>
+      </p:sp>
+      <p:sp>
+        <p:nvSpPr>
+          <p:cNvPr id="8" name="Shape 5"/>
+          <p:cNvSpPr/>
+          <p:nvPr/>
+        </p:nvSpPr>
+        <p:spPr>
+          <a:xfrm>
+            <a:off x="548640" y="2194560"/>
+            <a:ext cx="5362956" cy="3566160"/>
           </a:xfrm>
           <a:prstGeom prst="roundRect">
             <a:avLst>
-              <a:gd name="adj" fmla="val 2857"/>
+              <a:gd name="adj" fmla="val 3077"/>
             </a:avLst>
           </a:prstGeom>
           <a:solidFill>
@@ -11674,93 +14227,48 @@
             </a:solidFill>
             <a:prstDash val="solid"/>
           </a:ln>
-          <a:effectLst>
-            <a:outerShdw sx="100000" sy="100000" kx="0" ky="0" algn="bl" rotWithShape="0" blurRad="114300" dist="38100" dir="5400000">
-              <a:srgbClr val="AEC0C2">
-                <a:alpha val="55000"/>
-              </a:srgbClr>
-            </a:outerShdw>
-          </a:effectLst>
-        </p:spPr>
-      </p:sp>
-      <p:sp>
-        <p:nvSpPr>
-          <p:cNvPr id="8" name="Shape 5"/>
-          <p:cNvSpPr/>
-          <p:nvPr/>
-        </p:nvSpPr>
-        <p:spPr>
-          <a:xfrm>
-            <a:off x="548640" y="1691640"/>
-            <a:ext cx="6309360" cy="868680"/>
+        </p:spPr>
+        <p:txBody>
+          <a:bodyPr/>
+          <a:p/>
+        </p:txBody>
+      </p:sp>
+      <p:sp>
+        <p:nvSpPr>
+          <p:cNvPr id="9" name="Shape 6"/>
+          <p:cNvSpPr/>
+          <p:nvPr/>
+        </p:nvSpPr>
+        <p:spPr>
+          <a:xfrm>
+            <a:off x="548640" y="2194560"/>
+            <a:ext cx="5362956" cy="640080"/>
           </a:xfrm>
           <a:prstGeom prst="roundRect">
             <a:avLst>
-              <a:gd name="adj" fmla="val 12632"/>
+              <a:gd name="adj" fmla="val 17143"/>
             </a:avLst>
           </a:prstGeom>
           <a:solidFill>
-            <a:srgbClr val="0E2E34"/>
+            <a:srgbClr val="E0A02F"/>
           </a:solidFill>
           <a:ln/>
         </p:spPr>
-      </p:sp>
-      <p:sp>
-        <p:nvSpPr>
-          <p:cNvPr id="9" name="Shape 6"/>
-          <p:cNvSpPr/>
-          <p:nvPr/>
-        </p:nvSpPr>
-        <p:spPr>
-          <a:xfrm>
-            <a:off x="868680" y="1929384"/>
-            <a:ext cx="402336" cy="402336"/>
-          </a:xfrm>
-          <a:prstGeom prst="roundRect">
-            <a:avLst>
-              <a:gd name="adj" fmla="val 13636"/>
-            </a:avLst>
-          </a:prstGeom>
-          <a:solidFill>
-            <a:srgbClr val="02C39A"/>
-          </a:solidFill>
-          <a:ln/>
-        </p:spPr>
-      </p:sp>
-      <p:pic>
-        <p:nvPicPr>
-          <p:cNvPr id="10" name="Image 1" descr="preencoded.png">    </p:cNvPr>
-          <p:cNvPicPr>
-            <a:picLocks noChangeAspect="1"/>
-          </p:cNvPicPr>
-          <p:nvPr/>
-        </p:nvPicPr>
-        <p:blipFill>
-          <a:blip r:embed="rId2"/>
-          <a:stretch>
-            <a:fillRect/>
-          </a:stretch>
-        </p:blipFill>
-        <p:spPr>
-          <a:xfrm>
-            <a:off x="950976" y="2011680"/>
-            <a:ext cx="237744" cy="237744"/>
-          </a:xfrm>
-          <a:prstGeom prst="rect">
-            <a:avLst/>
-          </a:prstGeom>
-        </p:spPr>
-      </p:pic>
-      <p:sp>
-        <p:nvSpPr>
-          <p:cNvPr id="11" name="Text 7"/>
-          <p:cNvSpPr/>
-          <p:nvPr/>
-        </p:nvSpPr>
-        <p:spPr>
-          <a:xfrm>
-            <a:off x="1417320" y="1691640"/>
-            <a:ext cx="5212080" cy="868680"/>
+        <p:txBody>
+          <a:bodyPr/>
+          <a:p/>
+        </p:txBody>
+      </p:sp>
+      <p:sp>
+        <p:nvSpPr>
+          <p:cNvPr id="10" name="Text 7"/>
+          <p:cNvSpPr/>
+          <p:nvPr/>
+        </p:nvSpPr>
+        <p:spPr>
+          <a:xfrm>
+            <a:off x="822960" y="2194560"/>
+            <a:ext cx="4814316" cy="640080"/>
           </a:xfrm>
           <a:prstGeom prst="rect">
             <a:avLst/>
@@ -11776,7 +14284,7 @@
               <a:buNone/>
             </a:pPr>
             <a:r>
-              <a:rPr lang="en-US" sz="1700" b="1" dirty="0">
+              <a:rPr lang="en-US" sz="1600" b="1" dirty="0">
                 <a:solidFill>
                   <a:srgbClr val="FFFFFF"/>
                 </a:solidFill>
@@ -11784,484 +14292,22 @@
                 <a:ea typeface="Calibri" pitchFamily="34" charset="-122"/>
                 <a:cs typeface="Calibri" pitchFamily="34" charset="-120"/>
               </a:rPr>
-              <a:t>Appointment Management</a:t>
-            </a:r>
-            <a:endParaRPr lang="en-US" sz="1700" dirty="0"/>
-          </a:p>
-        </p:txBody>
-      </p:sp>
-      <p:sp>
-        <p:nvSpPr>
-          <p:cNvPr id="12" name="Shape 8"/>
-          <p:cNvSpPr/>
-          <p:nvPr/>
-        </p:nvSpPr>
-        <p:spPr>
-          <a:xfrm>
-            <a:off x="868680" y="2834640"/>
-            <a:ext cx="1335024" cy="502920"/>
-          </a:xfrm>
-          <a:prstGeom prst="roundRect">
-            <a:avLst>
-              <a:gd name="adj" fmla="val 50909"/>
-            </a:avLst>
-          </a:prstGeom>
-          <a:solidFill>
-            <a:srgbClr val="028090"/>
-          </a:solidFill>
-          <a:ln w="12700">
-            <a:solidFill>
-              <a:srgbClr val="D5E2E4"/>
-            </a:solidFill>
-            <a:prstDash val="solid"/>
-          </a:ln>
-        </p:spPr>
-      </p:sp>
-      <p:sp>
-        <p:nvSpPr>
-          <p:cNvPr id="13" name="Text 9"/>
-          <p:cNvSpPr/>
-          <p:nvPr/>
-        </p:nvSpPr>
-        <p:spPr>
-          <a:xfrm>
-            <a:off x="868680" y="2834640"/>
-            <a:ext cx="1335024" cy="502920"/>
-          </a:xfrm>
-          <a:prstGeom prst="rect">
-            <a:avLst/>
-          </a:prstGeom>
-          <a:noFill/>
-          <a:ln/>
-        </p:spPr>
-        <p:txBody>
-          <a:bodyPr wrap="square" rtlCol="0" anchor="ctr"/>
-          <a:lstStyle/>
-          <a:p>
-            <a:pPr algn="ctr" indent="0" marL="0">
-              <a:buNone/>
-            </a:pPr>
-            <a:r>
-              <a:rPr lang="en-US" sz="1150" b="1" dirty="0">
-                <a:solidFill>
-                  <a:srgbClr val="FFFFFF"/>
-                </a:solidFill>
-                <a:latin typeface="Calibri" pitchFamily="34" charset="0"/>
-                <a:ea typeface="Calibri" pitchFamily="34" charset="-122"/>
-                <a:cs typeface="Calibri" pitchFamily="34" charset="-120"/>
-              </a:rPr>
-              <a:t>Appointments</a:t>
-            </a:r>
-            <a:endParaRPr lang="en-US" sz="1150" dirty="0"/>
-          </a:p>
-        </p:txBody>
-      </p:sp>
-      <p:sp>
-        <p:nvSpPr>
-          <p:cNvPr id="14" name="Shape 10"/>
-          <p:cNvSpPr/>
-          <p:nvPr/>
-        </p:nvSpPr>
-        <p:spPr>
-          <a:xfrm>
-            <a:off x="2313432" y="2834640"/>
-            <a:ext cx="1335024" cy="502920"/>
-          </a:xfrm>
-          <a:prstGeom prst="roundRect">
-            <a:avLst>
-              <a:gd name="adj" fmla="val 50909"/>
-            </a:avLst>
-          </a:prstGeom>
-          <a:solidFill>
-            <a:srgbClr val="F1F6F7"/>
-          </a:solidFill>
-          <a:ln w="12700">
-            <a:solidFill>
-              <a:srgbClr val="D5E2E4"/>
-            </a:solidFill>
-            <a:prstDash val="solid"/>
-          </a:ln>
-        </p:spPr>
-      </p:sp>
-      <p:sp>
-        <p:nvSpPr>
-          <p:cNvPr id="15" name="Text 11"/>
-          <p:cNvSpPr/>
-          <p:nvPr/>
-        </p:nvSpPr>
-        <p:spPr>
-          <a:xfrm>
-            <a:off x="2313432" y="2834640"/>
-            <a:ext cx="1335024" cy="502920"/>
-          </a:xfrm>
-          <a:prstGeom prst="rect">
-            <a:avLst/>
-          </a:prstGeom>
-          <a:noFill/>
-          <a:ln/>
-        </p:spPr>
-        <p:txBody>
-          <a:bodyPr wrap="square" rtlCol="0" anchor="ctr"/>
-          <a:lstStyle/>
-          <a:p>
-            <a:pPr algn="ctr" indent="0" marL="0">
-              <a:buNone/>
-            </a:pPr>
-            <a:r>
-              <a:rPr lang="en-US" sz="1150" b="1" dirty="0">
-                <a:solidFill>
-                  <a:srgbClr val="5B7079"/>
-                </a:solidFill>
-                <a:latin typeface="Calibri" pitchFamily="34" charset="0"/>
-                <a:ea typeface="Calibri" pitchFamily="34" charset="-122"/>
-                <a:cs typeface="Calibri" pitchFamily="34" charset="-120"/>
-              </a:rPr>
-              <a:t>Contacts</a:t>
-            </a:r>
-            <a:endParaRPr lang="en-US" sz="1150" dirty="0"/>
-          </a:p>
-        </p:txBody>
-      </p:sp>
-      <p:sp>
-        <p:nvSpPr>
-          <p:cNvPr id="16" name="Shape 12"/>
-          <p:cNvSpPr/>
-          <p:nvPr/>
-        </p:nvSpPr>
-        <p:spPr>
-          <a:xfrm>
-            <a:off x="3758184" y="2834640"/>
-            <a:ext cx="1335024" cy="502920"/>
-          </a:xfrm>
-          <a:prstGeom prst="roundRect">
-            <a:avLst>
-              <a:gd name="adj" fmla="val 50909"/>
-            </a:avLst>
-          </a:prstGeom>
-          <a:solidFill>
-            <a:srgbClr val="F1F6F7"/>
-          </a:solidFill>
-          <a:ln w="12700">
-            <a:solidFill>
-              <a:srgbClr val="D5E2E4"/>
-            </a:solidFill>
-            <a:prstDash val="solid"/>
-          </a:ln>
-        </p:spPr>
-      </p:sp>
-      <p:sp>
-        <p:nvSpPr>
-          <p:cNvPr id="17" name="Text 13"/>
-          <p:cNvSpPr/>
-          <p:nvPr/>
-        </p:nvSpPr>
-        <p:spPr>
-          <a:xfrm>
-            <a:off x="3758184" y="2834640"/>
-            <a:ext cx="1335024" cy="502920"/>
-          </a:xfrm>
-          <a:prstGeom prst="rect">
-            <a:avLst/>
-          </a:prstGeom>
-          <a:noFill/>
-          <a:ln/>
-        </p:spPr>
-        <p:txBody>
-          <a:bodyPr wrap="square" rtlCol="0" anchor="ctr"/>
-          <a:lstStyle/>
-          <a:p>
-            <a:pPr algn="ctr" indent="0" marL="0">
-              <a:buNone/>
-            </a:pPr>
-            <a:r>
-              <a:rPr lang="en-US" sz="1150" b="1" dirty="0">
-                <a:solidFill>
-                  <a:srgbClr val="5B7079"/>
-                </a:solidFill>
-                <a:latin typeface="Calibri" pitchFamily="34" charset="0"/>
-                <a:ea typeface="Calibri" pitchFamily="34" charset="-122"/>
-                <a:cs typeface="Calibri" pitchFamily="34" charset="-120"/>
-              </a:rPr>
-              <a:t>Reports</a:t>
-            </a:r>
-            <a:endParaRPr lang="en-US" sz="1150" dirty="0"/>
-          </a:p>
-        </p:txBody>
-      </p:sp>
-      <p:sp>
-        <p:nvSpPr>
-          <p:cNvPr id="18" name="Shape 14"/>
-          <p:cNvSpPr/>
-          <p:nvPr/>
-        </p:nvSpPr>
-        <p:spPr>
-          <a:xfrm>
-            <a:off x="5202936" y="2834640"/>
-            <a:ext cx="1335024" cy="502920"/>
-          </a:xfrm>
-          <a:prstGeom prst="roundRect">
-            <a:avLst>
-              <a:gd name="adj" fmla="val 50909"/>
-            </a:avLst>
-          </a:prstGeom>
-          <a:solidFill>
-            <a:srgbClr val="F1F6F7"/>
-          </a:solidFill>
-          <a:ln w="12700">
-            <a:solidFill>
-              <a:srgbClr val="D5E2E4"/>
-            </a:solidFill>
-            <a:prstDash val="solid"/>
-          </a:ln>
-        </p:spPr>
-      </p:sp>
-      <p:sp>
-        <p:nvSpPr>
-          <p:cNvPr id="19" name="Text 15"/>
-          <p:cNvSpPr/>
-          <p:nvPr/>
-        </p:nvSpPr>
-        <p:spPr>
-          <a:xfrm>
-            <a:off x="5202936" y="2834640"/>
-            <a:ext cx="1335024" cy="502920"/>
-          </a:xfrm>
-          <a:prstGeom prst="rect">
-            <a:avLst/>
-          </a:prstGeom>
-          <a:noFill/>
-          <a:ln/>
-        </p:spPr>
-        <p:txBody>
-          <a:bodyPr wrap="square" rtlCol="0" anchor="ctr"/>
-          <a:lstStyle/>
-          <a:p>
-            <a:pPr algn="ctr" indent="0" marL="0">
-              <a:buNone/>
-            </a:pPr>
-            <a:r>
-              <a:rPr lang="en-US" sz="1150" b="1" dirty="0">
-                <a:solidFill>
-                  <a:srgbClr val="5B7079"/>
-                </a:solidFill>
-                <a:latin typeface="Calibri" pitchFamily="34" charset="0"/>
-                <a:ea typeface="Calibri" pitchFamily="34" charset="-122"/>
-                <a:cs typeface="Calibri" pitchFamily="34" charset="-120"/>
-              </a:rPr>
-              <a:t>Dashboards</a:t>
-            </a:r>
-            <a:endParaRPr lang="en-US" sz="1150" dirty="0"/>
-          </a:p>
-        </p:txBody>
-      </p:sp>
-      <p:sp>
-        <p:nvSpPr>
-          <p:cNvPr id="20" name="Shape 16"/>
-          <p:cNvSpPr/>
-          <p:nvPr/>
-        </p:nvSpPr>
-        <p:spPr>
-          <a:xfrm>
-            <a:off x="868680" y="3566160"/>
-            <a:ext cx="5669280" cy="457200"/>
-          </a:xfrm>
-          <a:prstGeom prst="roundRect">
-            <a:avLst>
-              <a:gd name="adj" fmla="val 12000"/>
-            </a:avLst>
-          </a:prstGeom>
-          <a:solidFill>
-            <a:srgbClr val="F1F6F7"/>
-          </a:solidFill>
-          <a:ln w="12700">
-            <a:solidFill>
-              <a:srgbClr val="D5E2E4"/>
-            </a:solidFill>
-            <a:prstDash val="solid"/>
-          </a:ln>
-        </p:spPr>
-      </p:sp>
-      <p:sp>
-        <p:nvSpPr>
-          <p:cNvPr id="21" name="Text 17"/>
-          <p:cNvSpPr/>
-          <p:nvPr/>
-        </p:nvSpPr>
-        <p:spPr>
-          <a:xfrm>
-            <a:off x="1051560" y="3566160"/>
-            <a:ext cx="5394960" cy="457200"/>
-          </a:xfrm>
-          <a:prstGeom prst="rect">
-            <a:avLst/>
-          </a:prstGeom>
-          <a:noFill/>
-          <a:ln/>
-        </p:spPr>
-        <p:txBody>
-          <a:bodyPr wrap="square" rtlCol="0" anchor="ctr"/>
-          <a:lstStyle/>
-          <a:p>
-            <a:pPr algn="l" indent="0" marL="0">
-              <a:buNone/>
-            </a:pPr>
-            <a:r>
-              <a:rPr lang="en-US" sz="1200" dirty="0">
-                <a:solidFill>
-                  <a:srgbClr val="0E2E34"/>
-                </a:solidFill>
-                <a:latin typeface="Courier New" pitchFamily="34" charset="0"/>
-                <a:ea typeface="Courier New" pitchFamily="34" charset="-122"/>
-                <a:cs typeface="Courier New" pitchFamily="34" charset="-120"/>
-              </a:rPr>
-              <a:t>APT-00001   ·   Scheduled</a:t>
-            </a:r>
-            <a:endParaRPr lang="en-US" sz="1200" dirty="0"/>
-          </a:p>
-        </p:txBody>
-      </p:sp>
-      <p:sp>
-        <p:nvSpPr>
-          <p:cNvPr id="22" name="Shape 18"/>
-          <p:cNvSpPr/>
-          <p:nvPr/>
-        </p:nvSpPr>
-        <p:spPr>
-          <a:xfrm>
-            <a:off x="868680" y="4133088"/>
-            <a:ext cx="5669280" cy="457200"/>
-          </a:xfrm>
-          <a:prstGeom prst="roundRect">
-            <a:avLst>
-              <a:gd name="adj" fmla="val 12000"/>
-            </a:avLst>
-          </a:prstGeom>
-          <a:solidFill>
-            <a:srgbClr val="FFFFFF"/>
-          </a:solidFill>
-          <a:ln w="12700">
-            <a:solidFill>
-              <a:srgbClr val="D5E2E4"/>
-            </a:solidFill>
-            <a:prstDash val="solid"/>
-          </a:ln>
-        </p:spPr>
-      </p:sp>
-      <p:sp>
-        <p:nvSpPr>
-          <p:cNvPr id="23" name="Text 19"/>
-          <p:cNvSpPr/>
-          <p:nvPr/>
-        </p:nvSpPr>
-        <p:spPr>
-          <a:xfrm>
-            <a:off x="1051560" y="4133088"/>
-            <a:ext cx="5394960" cy="457200"/>
-          </a:xfrm>
-          <a:prstGeom prst="rect">
-            <a:avLst/>
-          </a:prstGeom>
-          <a:noFill/>
-          <a:ln/>
-        </p:spPr>
-        <p:txBody>
-          <a:bodyPr wrap="square" rtlCol="0" anchor="ctr"/>
-          <a:lstStyle/>
-          <a:p>
-            <a:pPr algn="l" indent="0" marL="0">
-              <a:buNone/>
-            </a:pPr>
-            <a:r>
-              <a:rPr lang="en-US" sz="1200" dirty="0">
-                <a:solidFill>
-                  <a:srgbClr val="0E2E34"/>
-                </a:solidFill>
-                <a:latin typeface="Courier New" pitchFamily="34" charset="0"/>
-                <a:ea typeface="Courier New" pitchFamily="34" charset="-122"/>
-                <a:cs typeface="Courier New" pitchFamily="34" charset="-120"/>
-              </a:rPr>
-              <a:t>APT-00002   ·   Scheduled</a:t>
-            </a:r>
-            <a:endParaRPr lang="en-US" sz="1200" dirty="0"/>
-          </a:p>
-        </p:txBody>
-      </p:sp>
-      <p:sp>
-        <p:nvSpPr>
-          <p:cNvPr id="24" name="Shape 20"/>
-          <p:cNvSpPr/>
-          <p:nvPr/>
-        </p:nvSpPr>
-        <p:spPr>
-          <a:xfrm>
-            <a:off x="868680" y="4700016"/>
-            <a:ext cx="5669280" cy="457200"/>
-          </a:xfrm>
-          <a:prstGeom prst="roundRect">
-            <a:avLst>
-              <a:gd name="adj" fmla="val 12000"/>
-            </a:avLst>
-          </a:prstGeom>
-          <a:solidFill>
-            <a:srgbClr val="F1F6F7"/>
-          </a:solidFill>
-          <a:ln w="12700">
-            <a:solidFill>
-              <a:srgbClr val="D5E2E4"/>
-            </a:solidFill>
-            <a:prstDash val="solid"/>
-          </a:ln>
-        </p:spPr>
-      </p:sp>
-      <p:sp>
-        <p:nvSpPr>
-          <p:cNvPr id="25" name="Text 21"/>
-          <p:cNvSpPr/>
-          <p:nvPr/>
-        </p:nvSpPr>
-        <p:spPr>
-          <a:xfrm>
-            <a:off x="1051560" y="4700016"/>
-            <a:ext cx="5394960" cy="457200"/>
-          </a:xfrm>
-          <a:prstGeom prst="rect">
-            <a:avLst/>
-          </a:prstGeom>
-          <a:noFill/>
-          <a:ln/>
-        </p:spPr>
-        <p:txBody>
-          <a:bodyPr wrap="square" rtlCol="0" anchor="ctr"/>
-          <a:lstStyle/>
-          <a:p>
-            <a:pPr algn="l" indent="0" marL="0">
-              <a:buNone/>
-            </a:pPr>
-            <a:r>
-              <a:rPr lang="en-US" sz="1200" dirty="0">
-                <a:solidFill>
-                  <a:srgbClr val="0E2E34"/>
-                </a:solidFill>
-                <a:latin typeface="Courier New" pitchFamily="34" charset="0"/>
-                <a:ea typeface="Courier New" pitchFamily="34" charset="-122"/>
-                <a:cs typeface="Courier New" pitchFamily="34" charset="-120"/>
-              </a:rPr>
-              <a:t>APT-00003   ·   Scheduled</a:t>
-            </a:r>
-            <a:endParaRPr lang="en-US" sz="1200" dirty="0"/>
-          </a:p>
-        </p:txBody>
-      </p:sp>
-      <p:sp>
-        <p:nvSpPr>
-          <p:cNvPr id="26" name="Text 22"/>
-          <p:cNvSpPr/>
-          <p:nvPr/>
-        </p:nvSpPr>
-        <p:spPr>
-          <a:xfrm>
-            <a:off x="7086600" y="1828800"/>
-            <a:ext cx="4572000" cy="3657600"/>
+              <a:t>What It Does</a:t>
+            </a:r>
+            <a:endParaRPr lang="en-US" sz="1600" dirty="0"/>
+          </a:p>
+        </p:txBody>
+      </p:sp>
+      <p:sp>
+        <p:nvSpPr>
+          <p:cNvPr id="11" name="Text 8"/>
+          <p:cNvSpPr/>
+          <p:nvPr/>
+        </p:nvSpPr>
+        <p:spPr>
+          <a:xfrm>
+            <a:off x="822960" y="3063240"/>
+            <a:ext cx="4814316" cy="2560320"/>
           </a:xfrm>
           <a:prstGeom prst="rect">
             <a:avLst/>
@@ -12275,13 +14321,13 @@
           <a:p>
             <a:pPr algn="l" marL="203200" indent="-203200">
               <a:spcAft>
-                <a:spcPts val="1400"/>
+                <a:spcPts val="1200"/>
               </a:spcAft>
               <a:buSzPct val="100000"/>
               <a:buChar char="•"/>
             </a:pPr>
             <a:r>
-              <a:rPr lang="en-US" sz="1500" dirty="0">
+              <a:rPr lang="en-US" sz="1400" dirty="0">
                 <a:solidFill>
                   <a:srgbClr val="0E2E34"/>
                 </a:solidFill>
@@ -12289,20 +14335,20 @@
                 <a:ea typeface="Calibri" pitchFamily="34" charset="-122"/>
                 <a:cs typeface="Calibri" pitchFamily="34" charset="-120"/>
               </a:rPr>
-              <a:t>"Appointment Management" Lightning App.</a:t>
-            </a:r>
-            <a:endParaRPr lang="en-US" sz="1500" dirty="0"/>
+              <a:t>Lists the next upcoming, non-cancelled appointments, soonest first.</a:t>
+            </a:r>
+            <a:endParaRPr lang="en-US" sz="1400" dirty="0"/>
           </a:p>
           <a:p>
             <a:pPr algn="l" marL="203200" indent="-203200">
               <a:spcAft>
-                <a:spcPts val="1400"/>
+                <a:spcPts val="1200"/>
               </a:spcAft>
               <a:buSzPct val="100000"/>
               <a:buChar char="•"/>
             </a:pPr>
             <a:r>
-              <a:rPr lang="en-US" sz="1500" dirty="0">
+              <a:rPr lang="en-US" sz="1400" dirty="0">
                 <a:solidFill>
                   <a:srgbClr val="0E2E34"/>
                 </a:solidFill>
@@ -12310,51 +14356,9 @@
                 <a:ea typeface="Calibri" pitchFamily="34" charset="-122"/>
                 <a:cs typeface="Calibri" pitchFamily="34" charset="-120"/>
               </a:rPr>
-              <a:t>Tabs: Appointments, Contacts, Reports, Dashboards.</a:t>
-            </a:r>
-            <a:endParaRPr lang="en-US" sz="1500" dirty="0"/>
-          </a:p>
-          <a:p>
-            <a:pPr algn="l" marL="203200" indent="-203200">
-              <a:spcAft>
-                <a:spcPts val="1400"/>
-              </a:spcAft>
-              <a:buSzPct val="100000"/>
-              <a:buChar char="•"/>
-            </a:pPr>
-            <a:r>
-              <a:rPr lang="en-US" sz="1500" dirty="0">
-                <a:solidFill>
-                  <a:srgbClr val="0E2E34"/>
-                </a:solidFill>
-                <a:latin typeface="Calibri" pitchFamily="34" charset="0"/>
-                <a:ea typeface="Calibri" pitchFamily="34" charset="-122"/>
-                <a:cs typeface="Calibri" pitchFamily="34" charset="-120"/>
-              </a:rPr>
-              <a:t>Custom Tab created for the Appointment object.</a:t>
-            </a:r>
-            <a:endParaRPr lang="en-US" sz="1500" dirty="0"/>
-          </a:p>
-          <a:p>
-            <a:pPr algn="l" marL="203200" indent="-203200">
-              <a:spcAft>
-                <a:spcPts val="1400"/>
-              </a:spcAft>
-              <a:buSzPct val="100000"/>
-              <a:buChar char="•"/>
-            </a:pPr>
-            <a:r>
-              <a:rPr lang="en-US" sz="1500" dirty="0">
-                <a:solidFill>
-                  <a:srgbClr val="0E2E34"/>
-                </a:solidFill>
-                <a:latin typeface="Calibri" pitchFamily="34" charset="0"/>
-                <a:ea typeface="Calibri" pitchFamily="34" charset="-122"/>
-                <a:cs typeface="Calibri" pitchFamily="34" charset="-120"/>
-              </a:rPr>
-              <a:t>Assigned to the System Administrator profile.</a:t>
-            </a:r>
-            <a:endParaRPr lang="en-US" sz="1500" dirty="0"/>
+              <a:t>Shows appointment number, customer, date/time, service and status.</a:t>
+            </a:r>
+            <a:endParaRPr lang="en-US" sz="1400" dirty="0"/>
           </a:p>
           <a:p>
             <a:pPr algn="l" marL="203200" indent="-203200">
@@ -12362,7 +14366,7 @@
               <a:buChar char="•"/>
             </a:pPr>
             <a:r>
-              <a:rPr lang="en-US" sz="1500" dirty="0">
+              <a:rPr lang="en-US" sz="1400" dirty="0">
                 <a:solidFill>
                   <a:srgbClr val="0E2E34"/>
                 </a:solidFill>
@@ -12370,235 +14374,26 @@
                 <a:ea typeface="Calibri" pitchFamily="34" charset="-122"/>
                 <a:cs typeface="Calibri" pitchFamily="34" charset="-120"/>
               </a:rPr>
-              <a:t>Central workspace for agents and admins.</a:t>
-            </a:r>
-            <a:endParaRPr lang="en-US" sz="1500" dirty="0"/>
-          </a:p>
-        </p:txBody>
-      </p:sp>
-      <p:sp>
-        <p:nvSpPr>
-          <p:cNvPr id="27" name="Text 23"/>
-          <p:cNvSpPr/>
-          <p:nvPr/>
-        </p:nvSpPr>
-        <p:spPr>
-          <a:xfrm>
-            <a:off x="548640" y="6446520"/>
-            <a:ext cx="8229600" cy="274320"/>
-          </a:xfrm>
-          <a:prstGeom prst="rect">
-            <a:avLst/>
-          </a:prstGeom>
-          <a:noFill/>
-          <a:ln/>
-        </p:spPr>
-        <p:txBody>
-          <a:bodyPr wrap="square" rtlCol="0" anchor="ctr"/>
-          <a:lstStyle/>
-          <a:p>
-            <a:pPr algn="l" indent="0" marL="0">
-              <a:buNone/>
-            </a:pPr>
-            <a:r>
-              <a:rPr lang="en-US" sz="900" dirty="0">
-                <a:solidFill>
-                  <a:srgbClr val="5B7079"/>
-                </a:solidFill>
-                <a:latin typeface="Calibri" pitchFamily="34" charset="0"/>
-                <a:ea typeface="Calibri" pitchFamily="34" charset="-122"/>
-                <a:cs typeface="Calibri" pitchFamily="34" charset="-120"/>
-              </a:rPr>
-              <a:t>AI-Powered Appointment Management Assistant  ·  Salesforce Capstone</a:t>
-            </a:r>
-            <a:endParaRPr lang="en-US" sz="900" dirty="0"/>
-          </a:p>
-        </p:txBody>
-      </p:sp>
-    </p:spTree>
-  </p:cSld>
-  <p:clrMapOvr>
-    <a:masterClrMapping/>
-  </p:clrMapOvr>
-</p:sld>
-</file>
-
-<file path=ppt/slides/slide9.xml><?xml version="1.0" encoding="utf-8"?>
-<p:sld xmlns:a="http://schemas.openxmlformats.org/drawingml/2006/main" xmlns:r="http://schemas.openxmlformats.org/officeDocument/2006/relationships" xmlns:p="http://schemas.openxmlformats.org/presentationml/2006/main">
-  <p:cSld name="Slide 9">
-    <p:spTree>
-      <p:nvGrpSpPr>
-        <p:cNvPr id="1" name=""/>
-        <p:cNvGrpSpPr/>
-        <p:nvPr/>
-      </p:nvGrpSpPr>
-      <p:grpSpPr>
-        <a:xfrm>
-          <a:off x="0" y="0"/>
-          <a:ext cx="0" cy="0"/>
-          <a:chOff x="0" y="0"/>
-          <a:chExt cx="0" cy="0"/>
-        </a:xfrm>
-      </p:grpSpPr>
-      <p:sp>
-        <p:nvSpPr>
-          <p:cNvPr id="2" name="Shape 0"/>
-          <p:cNvSpPr/>
-          <p:nvPr/>
-        </p:nvSpPr>
-        <p:spPr>
-          <a:xfrm>
-            <a:off x="548640" y="475488"/>
-            <a:ext cx="585216" cy="585216"/>
-          </a:xfrm>
-          <a:prstGeom prst="ellipse">
-            <a:avLst/>
-          </a:prstGeom>
-          <a:solidFill>
-            <a:srgbClr val="028090"/>
-          </a:solidFill>
-          <a:ln/>
-        </p:spPr>
-      </p:sp>
-      <p:pic>
-        <p:nvPicPr>
-          <p:cNvPr id="3" name="Image 0" descr="preencoded.png">    </p:cNvPr>
-          <p:cNvPicPr>
-            <a:picLocks noChangeAspect="1"/>
-          </p:cNvPicPr>
-          <p:nvPr/>
-        </p:nvPicPr>
-        <p:blipFill>
-          <a:blip r:embed="rId1"/>
-          <a:stretch>
-            <a:fillRect/>
-          </a:stretch>
-        </p:blipFill>
-        <p:spPr>
-          <a:xfrm>
-            <a:off x="694944" y="621792"/>
-            <a:ext cx="292608" cy="292608"/>
-          </a:xfrm>
-          <a:prstGeom prst="rect">
-            <a:avLst/>
-          </a:prstGeom>
-        </p:spPr>
-      </p:pic>
-      <p:sp>
-        <p:nvSpPr>
-          <p:cNvPr id="4" name="Text 1"/>
-          <p:cNvSpPr/>
-          <p:nvPr/>
-        </p:nvSpPr>
-        <p:spPr>
-          <a:xfrm>
-            <a:off x="1335024" y="457200"/>
-            <a:ext cx="10030968" cy="621792"/>
-          </a:xfrm>
-          <a:prstGeom prst="rect">
-            <a:avLst/>
-          </a:prstGeom>
-          <a:noFill/>
-          <a:ln/>
-        </p:spPr>
-        <p:txBody>
-          <a:bodyPr wrap="square" lIns="0" tIns="0" rIns="0" bIns="0" rtlCol="0" anchor="ctr"/>
-          <a:lstStyle/>
-          <a:p>
-            <a:pPr algn="l" indent="0" marL="0">
-              <a:buNone/>
-            </a:pPr>
-            <a:r>
-              <a:rPr lang="en-US" sz="3000" b="1" dirty="0">
-                <a:solidFill>
-                  <a:srgbClr val="0E2E34"/>
-                </a:solidFill>
-                <a:latin typeface="Cambria" pitchFamily="34" charset="0"/>
-                <a:ea typeface="Cambria" pitchFamily="34" charset="-122"/>
-                <a:cs typeface="Cambria" pitchFamily="34" charset="-120"/>
-              </a:rPr>
-              <a:t>Reports &amp; Dashboard</a:t>
-            </a:r>
-            <a:endParaRPr lang="en-US" sz="3000" dirty="0"/>
-          </a:p>
-        </p:txBody>
-      </p:sp>
-      <p:sp>
-        <p:nvSpPr>
-          <p:cNvPr id="5" name="Text 2"/>
-          <p:cNvSpPr/>
-          <p:nvPr/>
-        </p:nvSpPr>
-        <p:spPr>
-          <a:xfrm>
-            <a:off x="11183112" y="502920"/>
-            <a:ext cx="457200" cy="530352"/>
-          </a:xfrm>
-          <a:prstGeom prst="rect">
-            <a:avLst/>
-          </a:prstGeom>
-          <a:noFill/>
-          <a:ln/>
-        </p:spPr>
-        <p:txBody>
-          <a:bodyPr wrap="square" rtlCol="0" anchor="ctr"/>
-          <a:lstStyle/>
-          <a:p>
-            <a:pPr algn="r" indent="0" marL="0">
-              <a:buNone/>
-            </a:pPr>
-            <a:r>
-              <a:rPr lang="en-US" sz="1300" b="1" dirty="0">
-                <a:solidFill>
-                  <a:srgbClr val="5B7079"/>
-                </a:solidFill>
-                <a:latin typeface="Calibri" pitchFamily="34" charset="0"/>
-                <a:ea typeface="Calibri" pitchFamily="34" charset="-122"/>
-                <a:cs typeface="Calibri" pitchFamily="34" charset="-120"/>
-              </a:rPr>
-              <a:t>9</a:t>
-            </a:r>
-            <a:endParaRPr lang="en-US" sz="1300" dirty="0"/>
-          </a:p>
-        </p:txBody>
-      </p:sp>
-      <p:sp>
-        <p:nvSpPr>
-          <p:cNvPr id="6" name="Shape 3"/>
-          <p:cNvSpPr/>
-          <p:nvPr/>
-        </p:nvSpPr>
-        <p:spPr>
-          <a:xfrm>
-            <a:off x="548640" y="1261872"/>
-            <a:ext cx="1005840" cy="0"/>
-          </a:xfrm>
-          <a:prstGeom prst="line">
-            <a:avLst/>
-          </a:prstGeom>
-          <a:noFill/>
-          <a:ln w="31750">
-            <a:solidFill>
-              <a:srgbClr val="02C39A"/>
-            </a:solidFill>
-            <a:prstDash val="solid"/>
-          </a:ln>
-        </p:spPr>
-      </p:sp>
-      <p:sp>
-        <p:nvSpPr>
-          <p:cNvPr id="7" name="Shape 4"/>
-          <p:cNvSpPr/>
-          <p:nvPr/>
-        </p:nvSpPr>
-        <p:spPr>
-          <a:xfrm>
-            <a:off x="548640" y="1600200"/>
-            <a:ext cx="6126480" cy="4297680"/>
+              <a:t>Clean empty state and a friendly error state — never a blank card.</a:t>
+            </a:r>
+            <a:endParaRPr lang="en-US" sz="1400" dirty="0"/>
+          </a:p>
+        </p:txBody>
+      </p:sp>
+      <p:sp>
+        <p:nvSpPr>
+          <p:cNvPr id="12" name="Shape 9"/>
+          <p:cNvSpPr/>
+          <p:nvPr/>
+        </p:nvSpPr>
+        <p:spPr>
+          <a:xfrm>
+            <a:off x="6277356" y="2194560"/>
+            <a:ext cx="5362956" cy="3566160"/>
           </a:xfrm>
           <a:prstGeom prst="roundRect">
             <a:avLst>
-              <a:gd name="adj" fmla="val 2553"/>
+              <a:gd name="adj" fmla="val 3077"/>
             </a:avLst>
           </a:prstGeom>
           <a:solidFill>
@@ -12610,25 +14405,48 @@
             </a:solidFill>
             <a:prstDash val="solid"/>
           </a:ln>
-          <a:effectLst>
-            <a:outerShdw sx="100000" sy="100000" kx="0" ky="0" algn="bl" rotWithShape="0" blurRad="88900" dist="25400" dir="5400000">
-              <a:srgbClr val="BCCBCD">
-                <a:alpha val="50000"/>
-              </a:srgbClr>
-            </a:outerShdw>
-          </a:effectLst>
-        </p:spPr>
-      </p:sp>
-      <p:sp>
-        <p:nvSpPr>
-          <p:cNvPr id="8" name="Text 5"/>
-          <p:cNvSpPr/>
-          <p:nvPr/>
-        </p:nvSpPr>
-        <p:spPr>
-          <a:xfrm>
-            <a:off x="822960" y="1783080"/>
-            <a:ext cx="5577840" cy="365760"/>
+        </p:spPr>
+        <p:txBody>
+          <a:bodyPr/>
+          <a:p/>
+        </p:txBody>
+      </p:sp>
+      <p:sp>
+        <p:nvSpPr>
+          <p:cNvPr id="13" name="Shape 10"/>
+          <p:cNvSpPr/>
+          <p:nvPr/>
+        </p:nvSpPr>
+        <p:spPr>
+          <a:xfrm>
+            <a:off x="6277356" y="2194560"/>
+            <a:ext cx="5362956" cy="640080"/>
+          </a:xfrm>
+          <a:prstGeom prst="roundRect">
+            <a:avLst>
+              <a:gd name="adj" fmla="val 17143"/>
+            </a:avLst>
+          </a:prstGeom>
+          <a:solidFill>
+            <a:srgbClr val="00A896"/>
+          </a:solidFill>
+          <a:ln/>
+        </p:spPr>
+        <p:txBody>
+          <a:bodyPr/>
+          <a:p/>
+        </p:txBody>
+      </p:sp>
+      <p:sp>
+        <p:nvSpPr>
+          <p:cNvPr id="14" name="Text 11"/>
+          <p:cNvSpPr/>
+          <p:nvPr/>
+        </p:nvSpPr>
+        <p:spPr>
+          <a:xfrm>
+            <a:off x="6551676" y="2194560"/>
+            <a:ext cx="4814316" cy="640080"/>
           </a:xfrm>
           <a:prstGeom prst="rect">
             <a:avLst/>
@@ -12644,46 +14462,30 @@
               <a:buNone/>
             </a:pPr>
             <a:r>
-              <a:rPr lang="en-US" sz="1500" b="1" dirty="0">
-                <a:solidFill>
-                  <a:srgbClr val="0E2E34"/>
-                </a:solidFill>
-                <a:latin typeface="Calibri" pitchFamily="34" charset="0"/>
-                <a:ea typeface="Calibri" pitchFamily="34" charset="-122"/>
-                <a:cs typeface="Calibri" pitchFamily="34" charset="-120"/>
-              </a:rPr>
-              <a:t>Appointments by Status</a:t>
-            </a:r>
-            <a:endParaRPr lang="en-US" sz="1500" dirty="0"/>
-          </a:p>
-        </p:txBody>
-      </p:sp>
-      <p:graphicFrame>
-        <p:nvGraphicFramePr>
-          <p:cNvPr id="9" name="Chart 0" descr=""/>
-          <p:cNvGraphicFramePr/>
-          <p:nvPr/>
-        </p:nvGraphicFramePr>
-        <p:xfrm>
-          <a:off x="777240" y="2194560"/>
-          <a:ext cx="5669280" cy="3429000"/>
-        </p:xfrm>
-        <a:graphic xmlns:a="http://schemas.openxmlformats.org/drawingml/2006/main">
-          <a:graphicData uri="http://schemas.openxmlformats.org/drawingml/2006/chart">
-            <c:chart xmlns:c="http://schemas.openxmlformats.org/drawingml/2006/chart" r:id="rId2"/>
-          </a:graphicData>
-        </a:graphic>
-      </p:graphicFrame>
-      <p:sp>
-        <p:nvSpPr>
-          <p:cNvPr id="10" name="Text 6"/>
-          <p:cNvSpPr/>
-          <p:nvPr/>
-        </p:nvSpPr>
-        <p:spPr>
-          <a:xfrm>
-            <a:off x="6995160" y="1920240"/>
-            <a:ext cx="4617720" cy="3291840"/>
+              <a:rPr lang="en-US" sz="1600" b="1" dirty="0">
+                <a:solidFill>
+                  <a:srgbClr val="FFFFFF"/>
+                </a:solidFill>
+                <a:latin typeface="Calibri" pitchFamily="34" charset="0"/>
+                <a:ea typeface="Calibri" pitchFamily="34" charset="-122"/>
+                <a:cs typeface="Calibri" pitchFamily="34" charset="-120"/>
+              </a:rPr>
+              <a:t>How It Is Built</a:t>
+            </a:r>
+            <a:endParaRPr lang="en-US" sz="1600" dirty="0"/>
+          </a:p>
+        </p:txBody>
+      </p:sp>
+      <p:sp>
+        <p:nvSpPr>
+          <p:cNvPr id="15" name="Text 12"/>
+          <p:cNvSpPr/>
+          <p:nvPr/>
+        </p:nvSpPr>
+        <p:spPr>
+          <a:xfrm>
+            <a:off x="6551676" y="3063240"/>
+            <a:ext cx="4814316" cy="2560320"/>
           </a:xfrm>
           <a:prstGeom prst="rect">
             <a:avLst/>
@@ -12697,13 +14499,13 @@
           <a:p>
             <a:pPr algn="l" marL="203200" indent="-203200">
               <a:spcAft>
-                <a:spcPts val="1300"/>
+                <a:spcPts val="1200"/>
               </a:spcAft>
               <a:buSzPct val="100000"/>
               <a:buChar char="•"/>
             </a:pPr>
             <a:r>
-              <a:rPr lang="en-US" sz="1450" dirty="0">
+              <a:rPr lang="en-US" sz="1400" dirty="0">
                 <a:solidFill>
                   <a:srgbClr val="0E2E34"/>
                 </a:solidFill>
@@ -12711,20 +14513,20 @@
                 <a:ea typeface="Calibri" pitchFamily="34" charset="-122"/>
                 <a:cs typeface="Calibri" pitchFamily="34" charset="-120"/>
               </a:rPr>
-              <a:t>Custom Report Type:  "Appointments Report".</a:t>
-            </a:r>
-            <a:endParaRPr lang="en-US" sz="1450" dirty="0"/>
+              <a:t>@wire to a cacheable Apex method — cached on the client, refreshed automatically.</a:t>
+            </a:r>
+            <a:endParaRPr lang="en-US" sz="1400" dirty="0"/>
           </a:p>
           <a:p>
             <a:pPr algn="l" marL="203200" indent="-203200">
               <a:spcAft>
-                <a:spcPts val="1300"/>
+                <a:spcPts val="1200"/>
               </a:spcAft>
               <a:buSzPct val="100000"/>
               <a:buChar char="•"/>
             </a:pPr>
             <a:r>
-              <a:rPr lang="en-US" sz="1450" dirty="0">
+              <a:rPr lang="en-US" sz="1400" dirty="0">
                 <a:solidFill>
                   <a:srgbClr val="0E2E34"/>
                 </a:solidFill>
@@ -12732,51 +14534,9 @@
                 <a:ea typeface="Calibri" pitchFamily="34" charset="-122"/>
                 <a:cs typeface="Calibri" pitchFamily="34" charset="-120"/>
               </a:rPr>
-              <a:t>Report:  "Appointments by Status" — grouped, with a chart.</a:t>
-            </a:r>
-            <a:endParaRPr lang="en-US" sz="1450" dirty="0"/>
-          </a:p>
-          <a:p>
-            <a:pPr algn="l" marL="203200" indent="-203200">
-              <a:spcAft>
-                <a:spcPts val="1300"/>
-              </a:spcAft>
-              <a:buSzPct val="100000"/>
-              <a:buChar char="•"/>
-            </a:pPr>
-            <a:r>
-              <a:rPr lang="en-US" sz="1450" dirty="0">
-                <a:solidFill>
-                  <a:srgbClr val="0E2E34"/>
-                </a:solidFill>
-                <a:latin typeface="Calibri" pitchFamily="34" charset="0"/>
-                <a:ea typeface="Calibri" pitchFamily="34" charset="-122"/>
-                <a:cs typeface="Calibri" pitchFamily="34" charset="-120"/>
-              </a:rPr>
-              <a:t>Dashboard:  "Appointments Dashboard" visualizing the data.</a:t>
-            </a:r>
-            <a:endParaRPr lang="en-US" sz="1450" dirty="0"/>
-          </a:p>
-          <a:p>
-            <a:pPr algn="l" marL="203200" indent="-203200">
-              <a:spcAft>
-                <a:spcPts val="1300"/>
-              </a:spcAft>
-              <a:buSzPct val="100000"/>
-              <a:buChar char="•"/>
-            </a:pPr>
-            <a:r>
-              <a:rPr lang="en-US" sz="1450" dirty="0">
-                <a:solidFill>
-                  <a:srgbClr val="0E2E34"/>
-                </a:solidFill>
-                <a:latin typeface="Calibri" pitchFamily="34" charset="0"/>
-                <a:ea typeface="Calibri" pitchFamily="34" charset="-122"/>
-                <a:cs typeface="Calibri" pitchFamily="34" charset="-120"/>
-              </a:rPr>
-              <a:t>Tracks Scheduled vs. Rescheduled vs. Cancelled at a glance.</a:t>
-            </a:r>
-            <a:endParaRPr lang="en-US" sz="1450" dirty="0"/>
+              <a:t>SOQL runs WITH USER_MODE, so the query respects the running user’s access.</a:t>
+            </a:r>
+            <a:endParaRPr lang="en-US" sz="1400" dirty="0"/>
           </a:p>
           <a:p>
             <a:pPr algn="l" marL="203200" indent="-203200">
@@ -12784,7 +14544,7 @@
               <a:buChar char="•"/>
             </a:pPr>
             <a:r>
-              <a:rPr lang="en-US" sz="1450" dirty="0">
+              <a:rPr lang="en-US" sz="1400" dirty="0">
                 <a:solidFill>
                   <a:srgbClr val="0E2E34"/>
                 </a:solidFill>
@@ -12792,54 +14552,15 @@
                 <a:ea typeface="Calibri" pitchFamily="34" charset="-122"/>
                 <a:cs typeface="Calibri" pitchFamily="34" charset="-120"/>
               </a:rPr>
-              <a:t>Supports data-driven operational decisions.</a:t>
-            </a:r>
-            <a:endParaRPr lang="en-US" sz="1450" dirty="0"/>
-          </a:p>
-        </p:txBody>
-      </p:sp>
-      <p:sp>
-        <p:nvSpPr>
-          <p:cNvPr id="11" name="Text 7"/>
-          <p:cNvSpPr/>
-          <p:nvPr/>
-        </p:nvSpPr>
-        <p:spPr>
-          <a:xfrm>
-            <a:off x="6995160" y="5257800"/>
-            <a:ext cx="4617720" cy="548640"/>
-          </a:xfrm>
-          <a:prstGeom prst="rect">
-            <a:avLst/>
-          </a:prstGeom>
-          <a:noFill/>
-          <a:ln/>
-        </p:spPr>
-        <p:txBody>
-          <a:bodyPr wrap="square" rtlCol="0" anchor="ctr"/>
-          <a:lstStyle/>
-          <a:p>
-            <a:pPr algn="l" indent="0" marL="0">
-              <a:buNone/>
-            </a:pPr>
-            <a:r>
-              <a:rPr lang="en-US" sz="1150" i="1" dirty="0">
-                <a:solidFill>
-                  <a:srgbClr val="5B7079"/>
-                </a:solidFill>
-                <a:latin typeface="Calibri" pitchFamily="34" charset="0"/>
-                <a:ea typeface="Calibri" pitchFamily="34" charset="-122"/>
-                <a:cs typeface="Calibri" pitchFamily="34" charset="-120"/>
-              </a:rPr>
-              <a:t>Chart reflects status transitions validated across the three test records.</a:t>
-            </a:r>
-            <a:endParaRPr lang="en-US" sz="1150" dirty="0"/>
-          </a:p>
-        </p:txBody>
-      </p:sp>
-      <p:sp>
-        <p:nvSpPr>
-          <p:cNvPr id="12" name="Text 8"/>
+              <a:t>Row count is a design attribute — configurable in App Builder, no code change.</a:t>
+            </a:r>
+            <a:endParaRPr lang="en-US" sz="1400" dirty="0"/>
+          </a:p>
+        </p:txBody>
+      </p:sp>
+      <p:sp>
+        <p:nvSpPr>
+          <p:cNvPr id="16" name="Text 13"/>
           <p:cNvSpPr/>
           <p:nvPr/>
         </p:nvSpPr>

</xml_diff>

<commit_message>
Document the active Einstein Bot as the honest Agentforce substitute
</commit_message>
<xml_diff>
--- a/Appointment_Assistant_Capstone.pptx
+++ b/Appointment_Assistant_Capstone.pptx
@@ -4605,7 +4605,7 @@
                 <a:ea typeface="Calibri" pitchFamily="34" charset="-122"/>
                 <a:cs typeface="Calibri" pitchFamily="34" charset="-120"/>
               </a:rPr>
-              <a:t>Delivered a fully working Screen Flow as an equivalent booking interface.</a:t>
+              <a:t>Delivered a working Screen Flow AND an active Einstein Bot, both calling the same Flows.</a:t>
             </a:r>
             <a:endParaRPr lang="en-US" sz="1400" dirty="0"/>
           </a:p>
@@ -6106,7 +6106,7 @@
                 <a:ea typeface="Calibri" pitchFamily="34" charset="-122"/>
                 <a:cs typeface="Calibri" pitchFamily="34" charset="-120"/>
               </a:rPr>
-              <a:t>A working alternative kept the project functional and on schedule.</a:t>
+              <a:t>Two working alternatives — Screen Flow and an active Einstein Bot — kept the project functional and on schedule.</a:t>
             </a:r>
             <a:endParaRPr lang="en-US" sz="1450" dirty="0"/>
           </a:p>

</xml_diff>